<commit_message>
Add Word report generator + benchmark/technique slides
- generate_report.py: builds a defense-ready docs/SwiftRoute_Report.docx (auto TOC, chapters, embedded benchmark charts, live numbers from summary.json).
- generate_presentation.py: new slides for the six optimisation techniques and benchmark results (embedded charts); adds an image-slide layout.
- requirements.txt: add python-docx for the report generator.
</commit_message>
<xml_diff>
--- a/docs/presentation.pptx
+++ b/docs/presentation.pptx
@@ -20,6 +20,9 @@
     <p:sldId id="268" r:id="rId19"/>
     <p:sldId id="269" r:id="rId20"/>
     <p:sldId id="270" r:id="rId21"/>
+    <p:sldId id="271" r:id="rId22"/>
+    <p:sldId id="272" r:id="rId23"/>
+    <p:sldId id="273" r:id="rId24"/>
   </p:sldIdLst>
   <p:sldSz cx="12191695" cy="6858000" type="screen4x3"/>
   <p:notesSz cx="6858000" cy="9144000"/>
@@ -3304,7 +3307,7 @@
                   <a:srgbClr val="FFFFFF"/>
                 </a:solidFill>
               </a:rPr>
-              <a:t>Difficult Choices &amp; Trade-offs</a:t>
+              <a:t>Benchmark: How Much Does It Save?</a:t>
             </a:r>
           </a:p>
         </p:txBody>
@@ -3317,8 +3320,8 @@
         </p:nvSpPr>
         <p:spPr>
           <a:xfrm>
-            <a:off x="822960" y="1554480"/>
-            <a:ext cx="10515600" cy="4937760"/>
+            <a:off x="822960" y="1325880"/>
+            <a:ext cx="10515600" cy="1280160"/>
           </a:xfrm>
           <a:prstGeom prst="rect">
             <a:avLst/>
@@ -3333,11 +3336,11 @@
           <a:p>
             <a:pPr>
               <a:spcAft>
-                <a:spcPts val="1400"/>
+                <a:spcPts val="600"/>
               </a:spcAft>
             </a:pPr>
             <a:r>
-              <a:rPr sz="2000" b="1">
+              <a:rPr sz="1600" b="1">
                 <a:solidFill>
                   <a:srgbClr val="EE6C4D"/>
                 </a:solidFill>
@@ -3345,22 +3348,22 @@
               <a:t>▸  </a:t>
             </a:r>
             <a:r>
-              <a:rPr sz="2000">
+              <a:rPr sz="1600">
                 <a:solidFill>
                   <a:srgbClr val="1F2933"/>
                 </a:solidFill>
               </a:rPr>
-              <a:t>SQLite vs PostgreSQL → support both via one DATABASE_URL.</a:t>
+              <a:t>Optimised routes cut total distance ~60–62% vs. naive FIFO dispatch.</a:t>
             </a:r>
           </a:p>
           <a:p>
             <a:pPr>
               <a:spcAft>
-                <a:spcPts val="1400"/>
+                <a:spcPts val="600"/>
               </a:spcAft>
             </a:pPr>
             <a:r>
-              <a:rPr sz="2000" b="1">
+              <a:rPr sz="1600" b="1">
                 <a:solidFill>
                   <a:srgbClr val="EE6C4D"/>
                 </a:solidFill>
@@ -3368,85 +3371,40 @@
               <a:t>▸  </a:t>
             </a:r>
             <a:r>
-              <a:rPr sz="2000">
+              <a:rPr sz="1600">
                 <a:solidFill>
                   <a:srgbClr val="1F2933"/>
                 </a:solidFill>
               </a:rPr>
-              <a:t>Heavy ML libraries → made optional, never required.</a:t>
-            </a:r>
-          </a:p>
-          <a:p>
-            <a:pPr>
-              <a:spcAft>
-                <a:spcPts val="1400"/>
-              </a:spcAft>
-            </a:pPr>
-            <a:r>
-              <a:rPr sz="2000" b="1">
-                <a:solidFill>
-                  <a:srgbClr val="EE6C4D"/>
-                </a:solidFill>
-              </a:rPr>
-              <a:t>▸  </a:t>
-            </a:r>
-            <a:r>
-              <a:rPr sz="2000">
-                <a:solidFill>
-                  <a:srgbClr val="1F2933"/>
-                </a:solidFill>
-              </a:rPr>
-              <a:t>Global vs project .env → self-contained config (a real bug we fixed).</a:t>
-            </a:r>
-          </a:p>
-          <a:p>
-            <a:pPr>
-              <a:spcAft>
-                <a:spcPts val="1400"/>
-              </a:spcAft>
-            </a:pPr>
-            <a:r>
-              <a:rPr sz="2000" b="1">
-                <a:solidFill>
-                  <a:srgbClr val="EE6C4D"/>
-                </a:solidFill>
-              </a:rPr>
-              <a:t>▸  </a:t>
-            </a:r>
-            <a:r>
-              <a:rPr sz="2000">
-                <a:solidFill>
-                  <a:srgbClr val="1F2933"/>
-                </a:solidFill>
-              </a:rPr>
-              <a:t>Geocoding vs “drop a pin” → map pin + landmark text.</a:t>
-            </a:r>
-          </a:p>
-          <a:p>
-            <a:pPr>
-              <a:spcAft>
-                <a:spcPts val="1400"/>
-              </a:spcAft>
-            </a:pPr>
-            <a:r>
-              <a:rPr sz="2000" b="1">
-                <a:solidFill>
-                  <a:srgbClr val="EE6C4D"/>
-                </a:solidFill>
-              </a:rPr>
-              <a:t>▸  </a:t>
-            </a:r>
-            <a:r>
-              <a:rPr sz="2000">
-                <a:solidFill>
-                  <a:srgbClr val="1F2933"/>
-                </a:solidFill>
-              </a:rPr>
-              <a:t>SPA vs server-rendered → server-rendered, single stack.</a:t>
-            </a:r>
-          </a:p>
-        </p:txBody>
-      </p:sp>
+              <a:t>40 random scenarios per size × sizes {8, 15, 25, 40}, fixed seed.</a:t>
+            </a:r>
+          </a:p>
+        </p:txBody>
+      </p:sp>
+      <p:pic>
+        <p:nvPicPr>
+          <p:cNvPr id="4" name="Picture 3" descr="improvement_by_strategy.png"/>
+          <p:cNvPicPr>
+            <a:picLocks noChangeAspect="1"/>
+          </p:cNvPicPr>
+          <p:nvPr/>
+        </p:nvPicPr>
+        <p:blipFill>
+          <a:blip r:embed="rId2"/>
+          <a:stretch>
+            <a:fillRect/>
+          </a:stretch>
+        </p:blipFill>
+        <p:spPr>
+          <a:xfrm>
+            <a:off x="2680563" y="2651760"/>
+            <a:ext cx="6827520" cy="3840480"/>
+          </a:xfrm>
+          <a:prstGeom prst="rect">
+            <a:avLst/>
+          </a:prstGeom>
+        </p:spPr>
+      </p:pic>
     </p:spTree>
   </p:cSld>
   <p:clrMapOvr>
@@ -3519,7 +3477,7 @@
                   <a:srgbClr val="FFFFFF"/>
                 </a:solidFill>
               </a:rPr>
-              <a:t>Security</a:t>
+              <a:t>Benchmark: Optimality &amp; Speed</a:t>
             </a:r>
           </a:p>
         </p:txBody>
@@ -3532,8 +3490,8 @@
         </p:nvSpPr>
         <p:spPr>
           <a:xfrm>
-            <a:off x="822960" y="1554480"/>
-            <a:ext cx="10515600" cy="4937760"/>
+            <a:off x="822960" y="1325880"/>
+            <a:ext cx="10515600" cy="1280160"/>
           </a:xfrm>
           <a:prstGeom prst="rect">
             <a:avLst/>
@@ -3548,11 +3506,11 @@
           <a:p>
             <a:pPr>
               <a:spcAft>
-                <a:spcPts val="1400"/>
+                <a:spcPts val="600"/>
               </a:spcAft>
             </a:pPr>
             <a:r>
-              <a:rPr sz="2000" b="1">
+              <a:rPr sz="1600" b="1">
                 <a:solidFill>
                   <a:srgbClr val="EE6C4D"/>
                 </a:solidFill>
@@ -3560,22 +3518,22 @@
               <a:t>▸  </a:t>
             </a:r>
             <a:r>
-              <a:rPr sz="2000">
+              <a:rPr sz="1600">
                 <a:solidFill>
                   <a:srgbClr val="1F2933"/>
                 </a:solidFill>
               </a:rPr>
-              <a:t>Passwords hashed with Werkzeug (PBKDF2).</a:t>
+              <a:t>On solvable instances, Or-opt is ~0.1% above optimal; 2-opt &amp; SA &lt; 1%.</a:t>
             </a:r>
           </a:p>
           <a:p>
             <a:pPr>
               <a:spcAft>
-                <a:spcPts val="1400"/>
+                <a:spcPts val="600"/>
               </a:spcAft>
             </a:pPr>
             <a:r>
-              <a:rPr sz="2000" b="1">
+              <a:rPr sz="1600" b="1">
                 <a:solidFill>
                   <a:srgbClr val="EE6C4D"/>
                 </a:solidFill>
@@ -3583,62 +3541,40 @@
               <a:t>▸  </a:t>
             </a:r>
             <a:r>
-              <a:rPr sz="2000">
+              <a:rPr sz="1600">
                 <a:solidFill>
                   <a:srgbClr val="1F2933"/>
                 </a:solidFill>
               </a:rPr>
-              <a:t>CSRF protection on every browser form.</a:t>
-            </a:r>
-          </a:p>
-          <a:p>
-            <a:pPr>
-              <a:spcAft>
-                <a:spcPts val="1400"/>
-              </a:spcAft>
-            </a:pPr>
-            <a:r>
-              <a:rPr sz="2000" b="1">
-                <a:solidFill>
-                  <a:srgbClr val="EE6C4D"/>
-                </a:solidFill>
-              </a:rPr>
-              <a:t>▸  </a:t>
-            </a:r>
-            <a:r>
-              <a:rPr sz="2000">
-                <a:solidFill>
-                  <a:srgbClr val="1F2933"/>
-                </a:solidFill>
-              </a:rPr>
-              <a:t>Role-based access control via a decorator.</a:t>
-            </a:r>
-          </a:p>
-          <a:p>
-            <a:pPr>
-              <a:spcAft>
-                <a:spcPts val="1400"/>
-              </a:spcAft>
-            </a:pPr>
-            <a:r>
-              <a:rPr sz="2000" b="1">
-                <a:solidFill>
-                  <a:srgbClr val="EE6C4D"/>
-                </a:solidFill>
-              </a:rPr>
-              <a:t>▸  </a:t>
-            </a:r>
-            <a:r>
-              <a:rPr sz="2000">
-                <a:solidFill>
-                  <a:srgbClr val="1F2933"/>
-                </a:solidFill>
-              </a:rPr>
-              <a:t>Server-side validation and open-redirect protection.</a:t>
-            </a:r>
-          </a:p>
-        </p:txBody>
-      </p:sp>
+              <a:t>2-opt gives the best quality/speed balance; Christofides scales gently.</a:t>
+            </a:r>
+          </a:p>
+        </p:txBody>
+      </p:sp>
+      <p:pic>
+        <p:nvPicPr>
+          <p:cNvPr id="4" name="Picture 3" descr="runtime_scaling.png"/>
+          <p:cNvPicPr>
+            <a:picLocks noChangeAspect="1"/>
+          </p:cNvPicPr>
+          <p:nvPr/>
+        </p:nvPicPr>
+        <p:blipFill>
+          <a:blip r:embed="rId2"/>
+          <a:stretch>
+            <a:fillRect/>
+          </a:stretch>
+        </p:blipFill>
+        <p:spPr>
+          <a:xfrm>
+            <a:off x="2680563" y="2651760"/>
+            <a:ext cx="6827520" cy="3840480"/>
+          </a:xfrm>
+          <a:prstGeom prst="rect">
+            <a:avLst/>
+          </a:prstGeom>
+        </p:spPr>
+      </p:pic>
     </p:spTree>
   </p:cSld>
   <p:clrMapOvr>
@@ -3711,7 +3647,7 @@
                   <a:srgbClr val="FFFFFF"/>
                 </a:solidFill>
               </a:rPr>
-              <a:t>Live Demo Flow</a:t>
+              <a:t>Shipment Lifecycle</a:t>
             </a:r>
           </a:p>
         </p:txBody>
@@ -3757,7 +3693,7 @@
                   <a:srgbClr val="1F2933"/>
                 </a:solidFill>
               </a:rPr>
-              <a:t>Merchant creates a shipment by dropping a pin on the map.</a:t>
+              <a:t>pending → at_warehouse → out_for_delivery → delivered.</a:t>
             </a:r>
           </a:p>
           <a:p>
@@ -3780,7 +3716,7 @@
                   <a:srgbClr val="1F2933"/>
                 </a:solidFill>
               </a:rPr>
-              <a:t>Admin marks it At-Warehouse and runs the optimiser.</a:t>
+              <a:t>Plus failed, returned and cancelled states.</a:t>
             </a:r>
           </a:p>
           <a:p>
@@ -3803,7 +3739,7 @@
                   <a:srgbClr val="1F2933"/>
                 </a:solidFill>
               </a:rPr>
-              <a:t>Courier sees the route, delivers, captures proof of delivery.</a:t>
+              <a:t>Every change is recorded as an immutable event.</a:t>
             </a:r>
           </a:p>
           <a:p>
@@ -3826,7 +3762,7 @@
                   <a:srgbClr val="1F2933"/>
                 </a:solidFill>
               </a:rPr>
-              <a:t>Anyone tracks the parcel publicly by its number.</a:t>
+              <a:t>The customer-facing timeline is built from these events.</a:t>
             </a:r>
           </a:p>
         </p:txBody>
@@ -3903,7 +3839,7 @@
                   <a:srgbClr val="FFFFFF"/>
                 </a:solidFill>
               </a:rPr>
-              <a:t>Testing &amp; Quality</a:t>
+              <a:t>Difficult Choices &amp; Trade-offs</a:t>
             </a:r>
           </a:p>
         </p:txBody>
@@ -3949,7 +3885,7 @@
                   <a:srgbClr val="1F2933"/>
                 </a:solidFill>
               </a:rPr>
-              <a:t>End-to-end tests over the real create → optimise → deliver → track flow.</a:t>
+              <a:t>SQLite vs PostgreSQL → support both via one DATABASE_URL.</a:t>
             </a:r>
           </a:p>
           <a:p>
@@ -3972,7 +3908,7 @@
                   <a:srgbClr val="1F2933"/>
                 </a:solidFill>
               </a:rPr>
-              <a:t>Role-protection tests ensure permissions hold.</a:t>
+              <a:t>Heavy ML libraries → made optional, never required.</a:t>
             </a:r>
           </a:p>
           <a:p>
@@ -3995,7 +3931,7 @@
                   <a:srgbClr val="1F2933"/>
                 </a:solidFill>
               </a:rPr>
-              <a:t>Optimiser test verifies routes are assigned and measured.</a:t>
+              <a:t>Global vs project .env → self-contained config (a real bug we fixed).</a:t>
             </a:r>
           </a:p>
           <a:p>
@@ -4018,7 +3954,30 @@
                   <a:srgbClr val="1F2933"/>
                 </a:solidFill>
               </a:rPr>
-              <a:t>All tests pass on the in-memory database.</a:t>
+              <a:t>Geocoding vs “drop a pin” → map pin + landmark text.</a:t>
+            </a:r>
+          </a:p>
+          <a:p>
+            <a:pPr>
+              <a:spcAft>
+                <a:spcPts val="1400"/>
+              </a:spcAft>
+            </a:pPr>
+            <a:r>
+              <a:rPr sz="2000" b="1">
+                <a:solidFill>
+                  <a:srgbClr val="EE6C4D"/>
+                </a:solidFill>
+              </a:rPr>
+              <a:t>▸  </a:t>
+            </a:r>
+            <a:r>
+              <a:rPr sz="2000">
+                <a:solidFill>
+                  <a:srgbClr val="1F2933"/>
+                </a:solidFill>
+              </a:rPr>
+              <a:t>SPA vs server-rendered → server-rendered, single stack.</a:t>
             </a:r>
           </a:p>
         </p:txBody>
@@ -4095,7 +4054,7 @@
                   <a:srgbClr val="FFFFFF"/>
                 </a:solidFill>
               </a:rPr>
-              <a:t>Future Work</a:t>
+              <a:t>Security</a:t>
             </a:r>
           </a:p>
         </p:txBody>
@@ -4141,7 +4100,7 @@
                   <a:srgbClr val="1F2933"/>
                 </a:solidFill>
               </a:rPr>
-              <a:t>SMS / email notifications on status changes.</a:t>
+              <a:t>Passwords hashed with Werkzeug (PBKDF2).</a:t>
             </a:r>
           </a:p>
           <a:p>
@@ -4164,7 +4123,7 @@
                   <a:srgbClr val="1F2933"/>
                 </a:solidFill>
               </a:rPr>
-              <a:t>Cash-on-delivery settlement and merchant payouts.</a:t>
+              <a:t>CSRF protection on every browser form.</a:t>
             </a:r>
           </a:p>
           <a:p>
@@ -4187,7 +4146,7 @@
                   <a:srgbClr val="1F2933"/>
                 </a:solidFill>
               </a:rPr>
-              <a:t>Live GPS tracking and a native courier mobile app.</a:t>
+              <a:t>Role-based access control via a decorator.</a:t>
             </a:r>
           </a:p>
           <a:p>
@@ -4210,7 +4169,7 @@
                   <a:srgbClr val="1F2933"/>
                 </a:solidFill>
               </a:rPr>
-              <a:t>ML-driven demand forecasting and dynamic re-routing.</a:t>
+              <a:t>Server-side validation and open-redirect protection.</a:t>
             </a:r>
           </a:p>
         </p:txBody>
@@ -4224,6 +4183,582 @@
 </file>
 
 <file path=ppt/slides/slide15.xml><?xml version="1.0" encoding="utf-8"?>
+<p:sld xmlns:a="http://schemas.openxmlformats.org/drawingml/2006/main" xmlns:p="http://schemas.openxmlformats.org/presentationml/2006/main" xmlns:r="http://schemas.openxmlformats.org/officeDocument/2006/relationships">
+  <p:cSld>
+    <p:bg>
+      <p:bgPr>
+        <a:solidFill>
+          <a:srgbClr val="F4F7FB"/>
+        </a:solidFill>
+        <a:effectLst/>
+      </p:bgPr>
+    </p:bg>
+    <p:spTree>
+      <p:nvGrpSpPr>
+        <p:cNvPr id="1" name=""/>
+        <p:cNvGrpSpPr/>
+        <p:nvPr/>
+      </p:nvGrpSpPr>
+      <p:grpSpPr/>
+      <p:sp>
+        <p:nvSpPr>
+          <p:cNvPr id="2" name="Rectangle 1"/>
+          <p:cNvSpPr/>
+          <p:nvPr/>
+        </p:nvSpPr>
+        <p:spPr>
+          <a:xfrm>
+            <a:off x="0" y="0"/>
+            <a:ext cx="12191695" cy="1143000"/>
+          </a:xfrm>
+          <a:prstGeom prst="rect">
+            <a:avLst/>
+          </a:prstGeom>
+          <a:solidFill>
+            <a:srgbClr val="0D3B66"/>
+          </a:solidFill>
+          <a:ln>
+            <a:noFill/>
+          </a:ln>
+        </p:spPr>
+        <p:style>
+          <a:lnRef idx="1">
+            <a:schemeClr val="accent1"/>
+          </a:lnRef>
+          <a:fillRef idx="3">
+            <a:schemeClr val="accent1"/>
+          </a:fillRef>
+          <a:effectRef idx="2">
+            <a:schemeClr val="accent1"/>
+          </a:effectRef>
+          <a:fontRef idx="minor">
+            <a:schemeClr val="lt1"/>
+          </a:fontRef>
+        </p:style>
+        <p:txBody>
+          <a:bodyPr rtlCol="0" anchor="ctr" wrap="square" lIns="548640"/>
+          <a:lstStyle/>
+          <a:p>
+            <a:pPr algn="ctr"/>
+            <a:r>
+              <a:rPr sz="3000" b="1">
+                <a:solidFill>
+                  <a:srgbClr val="FFFFFF"/>
+                </a:solidFill>
+              </a:rPr>
+              <a:t>Live Demo Flow</a:t>
+            </a:r>
+          </a:p>
+        </p:txBody>
+      </p:sp>
+      <p:sp>
+        <p:nvSpPr>
+          <p:cNvPr id="3" name="TextBox 2"/>
+          <p:cNvSpPr txBox="1"/>
+          <p:nvPr/>
+        </p:nvSpPr>
+        <p:spPr>
+          <a:xfrm>
+            <a:off x="822960" y="1554480"/>
+            <a:ext cx="10515600" cy="4937760"/>
+          </a:xfrm>
+          <a:prstGeom prst="rect">
+            <a:avLst/>
+          </a:prstGeom>
+          <a:noFill/>
+        </p:spPr>
+        <p:txBody>
+          <a:bodyPr wrap="square">
+            <a:spAutoFit/>
+          </a:bodyPr>
+          <a:lstStyle/>
+          <a:p>
+            <a:pPr>
+              <a:spcAft>
+                <a:spcPts val="1400"/>
+              </a:spcAft>
+            </a:pPr>
+            <a:r>
+              <a:rPr sz="2000" b="1">
+                <a:solidFill>
+                  <a:srgbClr val="EE6C4D"/>
+                </a:solidFill>
+              </a:rPr>
+              <a:t>▸  </a:t>
+            </a:r>
+            <a:r>
+              <a:rPr sz="2000">
+                <a:solidFill>
+                  <a:srgbClr val="1F2933"/>
+                </a:solidFill>
+              </a:rPr>
+              <a:t>Merchant creates a shipment by dropping a pin on the map.</a:t>
+            </a:r>
+          </a:p>
+          <a:p>
+            <a:pPr>
+              <a:spcAft>
+                <a:spcPts val="1400"/>
+              </a:spcAft>
+            </a:pPr>
+            <a:r>
+              <a:rPr sz="2000" b="1">
+                <a:solidFill>
+                  <a:srgbClr val="EE6C4D"/>
+                </a:solidFill>
+              </a:rPr>
+              <a:t>▸  </a:t>
+            </a:r>
+            <a:r>
+              <a:rPr sz="2000">
+                <a:solidFill>
+                  <a:srgbClr val="1F2933"/>
+                </a:solidFill>
+              </a:rPr>
+              <a:t>Admin marks it At-Warehouse and runs the optimiser.</a:t>
+            </a:r>
+          </a:p>
+          <a:p>
+            <a:pPr>
+              <a:spcAft>
+                <a:spcPts val="1400"/>
+              </a:spcAft>
+            </a:pPr>
+            <a:r>
+              <a:rPr sz="2000" b="1">
+                <a:solidFill>
+                  <a:srgbClr val="EE6C4D"/>
+                </a:solidFill>
+              </a:rPr>
+              <a:t>▸  </a:t>
+            </a:r>
+            <a:r>
+              <a:rPr sz="2000">
+                <a:solidFill>
+                  <a:srgbClr val="1F2933"/>
+                </a:solidFill>
+              </a:rPr>
+              <a:t>Courier sees the route, delivers, captures proof of delivery.</a:t>
+            </a:r>
+          </a:p>
+          <a:p>
+            <a:pPr>
+              <a:spcAft>
+                <a:spcPts val="1400"/>
+              </a:spcAft>
+            </a:pPr>
+            <a:r>
+              <a:rPr sz="2000" b="1">
+                <a:solidFill>
+                  <a:srgbClr val="EE6C4D"/>
+                </a:solidFill>
+              </a:rPr>
+              <a:t>▸  </a:t>
+            </a:r>
+            <a:r>
+              <a:rPr sz="2000">
+                <a:solidFill>
+                  <a:srgbClr val="1F2933"/>
+                </a:solidFill>
+              </a:rPr>
+              <a:t>Anyone tracks the parcel publicly by its number.</a:t>
+            </a:r>
+          </a:p>
+        </p:txBody>
+      </p:sp>
+    </p:spTree>
+  </p:cSld>
+  <p:clrMapOvr>
+    <a:masterClrMapping/>
+  </p:clrMapOvr>
+</p:sld>
+</file>
+
+<file path=ppt/slides/slide16.xml><?xml version="1.0" encoding="utf-8"?>
+<p:sld xmlns:a="http://schemas.openxmlformats.org/drawingml/2006/main" xmlns:p="http://schemas.openxmlformats.org/presentationml/2006/main" xmlns:r="http://schemas.openxmlformats.org/officeDocument/2006/relationships">
+  <p:cSld>
+    <p:bg>
+      <p:bgPr>
+        <a:solidFill>
+          <a:srgbClr val="F4F7FB"/>
+        </a:solidFill>
+        <a:effectLst/>
+      </p:bgPr>
+    </p:bg>
+    <p:spTree>
+      <p:nvGrpSpPr>
+        <p:cNvPr id="1" name=""/>
+        <p:cNvGrpSpPr/>
+        <p:nvPr/>
+      </p:nvGrpSpPr>
+      <p:grpSpPr/>
+      <p:sp>
+        <p:nvSpPr>
+          <p:cNvPr id="2" name="Rectangle 1"/>
+          <p:cNvSpPr/>
+          <p:nvPr/>
+        </p:nvSpPr>
+        <p:spPr>
+          <a:xfrm>
+            <a:off x="0" y="0"/>
+            <a:ext cx="12191695" cy="1143000"/>
+          </a:xfrm>
+          <a:prstGeom prst="rect">
+            <a:avLst/>
+          </a:prstGeom>
+          <a:solidFill>
+            <a:srgbClr val="0D3B66"/>
+          </a:solidFill>
+          <a:ln>
+            <a:noFill/>
+          </a:ln>
+        </p:spPr>
+        <p:style>
+          <a:lnRef idx="1">
+            <a:schemeClr val="accent1"/>
+          </a:lnRef>
+          <a:fillRef idx="3">
+            <a:schemeClr val="accent1"/>
+          </a:fillRef>
+          <a:effectRef idx="2">
+            <a:schemeClr val="accent1"/>
+          </a:effectRef>
+          <a:fontRef idx="minor">
+            <a:schemeClr val="lt1"/>
+          </a:fontRef>
+        </p:style>
+        <p:txBody>
+          <a:bodyPr rtlCol="0" anchor="ctr" wrap="square" lIns="548640"/>
+          <a:lstStyle/>
+          <a:p>
+            <a:pPr algn="ctr"/>
+            <a:r>
+              <a:rPr sz="3000" b="1">
+                <a:solidFill>
+                  <a:srgbClr val="FFFFFF"/>
+                </a:solidFill>
+              </a:rPr>
+              <a:t>Testing &amp; Quality</a:t>
+            </a:r>
+          </a:p>
+        </p:txBody>
+      </p:sp>
+      <p:sp>
+        <p:nvSpPr>
+          <p:cNvPr id="3" name="TextBox 2"/>
+          <p:cNvSpPr txBox="1"/>
+          <p:nvPr/>
+        </p:nvSpPr>
+        <p:spPr>
+          <a:xfrm>
+            <a:off x="822960" y="1554480"/>
+            <a:ext cx="10515600" cy="4937760"/>
+          </a:xfrm>
+          <a:prstGeom prst="rect">
+            <a:avLst/>
+          </a:prstGeom>
+          <a:noFill/>
+        </p:spPr>
+        <p:txBody>
+          <a:bodyPr wrap="square">
+            <a:spAutoFit/>
+          </a:bodyPr>
+          <a:lstStyle/>
+          <a:p>
+            <a:pPr>
+              <a:spcAft>
+                <a:spcPts val="1400"/>
+              </a:spcAft>
+            </a:pPr>
+            <a:r>
+              <a:rPr sz="2000" b="1">
+                <a:solidFill>
+                  <a:srgbClr val="EE6C4D"/>
+                </a:solidFill>
+              </a:rPr>
+              <a:t>▸  </a:t>
+            </a:r>
+            <a:r>
+              <a:rPr sz="2000">
+                <a:solidFill>
+                  <a:srgbClr val="1F2933"/>
+                </a:solidFill>
+              </a:rPr>
+              <a:t>End-to-end tests over the real create → optimise → deliver → track flow.</a:t>
+            </a:r>
+          </a:p>
+          <a:p>
+            <a:pPr>
+              <a:spcAft>
+                <a:spcPts val="1400"/>
+              </a:spcAft>
+            </a:pPr>
+            <a:r>
+              <a:rPr sz="2000" b="1">
+                <a:solidFill>
+                  <a:srgbClr val="EE6C4D"/>
+                </a:solidFill>
+              </a:rPr>
+              <a:t>▸  </a:t>
+            </a:r>
+            <a:r>
+              <a:rPr sz="2000">
+                <a:solidFill>
+                  <a:srgbClr val="1F2933"/>
+                </a:solidFill>
+              </a:rPr>
+              <a:t>Role-protection tests ensure permissions hold.</a:t>
+            </a:r>
+          </a:p>
+          <a:p>
+            <a:pPr>
+              <a:spcAft>
+                <a:spcPts val="1400"/>
+              </a:spcAft>
+            </a:pPr>
+            <a:r>
+              <a:rPr sz="2000" b="1">
+                <a:solidFill>
+                  <a:srgbClr val="EE6C4D"/>
+                </a:solidFill>
+              </a:rPr>
+              <a:t>▸  </a:t>
+            </a:r>
+            <a:r>
+              <a:rPr sz="2000">
+                <a:solidFill>
+                  <a:srgbClr val="1F2933"/>
+                </a:solidFill>
+              </a:rPr>
+              <a:t>Optimiser test verifies routes are assigned and measured.</a:t>
+            </a:r>
+          </a:p>
+          <a:p>
+            <a:pPr>
+              <a:spcAft>
+                <a:spcPts val="1400"/>
+              </a:spcAft>
+            </a:pPr>
+            <a:r>
+              <a:rPr sz="2000" b="1">
+                <a:solidFill>
+                  <a:srgbClr val="EE6C4D"/>
+                </a:solidFill>
+              </a:rPr>
+              <a:t>▸  </a:t>
+            </a:r>
+            <a:r>
+              <a:rPr sz="2000">
+                <a:solidFill>
+                  <a:srgbClr val="1F2933"/>
+                </a:solidFill>
+              </a:rPr>
+              <a:t>All tests pass on the in-memory database.</a:t>
+            </a:r>
+          </a:p>
+        </p:txBody>
+      </p:sp>
+    </p:spTree>
+  </p:cSld>
+  <p:clrMapOvr>
+    <a:masterClrMapping/>
+  </p:clrMapOvr>
+</p:sld>
+</file>
+
+<file path=ppt/slides/slide17.xml><?xml version="1.0" encoding="utf-8"?>
+<p:sld xmlns:a="http://schemas.openxmlformats.org/drawingml/2006/main" xmlns:p="http://schemas.openxmlformats.org/presentationml/2006/main" xmlns:r="http://schemas.openxmlformats.org/officeDocument/2006/relationships">
+  <p:cSld>
+    <p:bg>
+      <p:bgPr>
+        <a:solidFill>
+          <a:srgbClr val="F4F7FB"/>
+        </a:solidFill>
+        <a:effectLst/>
+      </p:bgPr>
+    </p:bg>
+    <p:spTree>
+      <p:nvGrpSpPr>
+        <p:cNvPr id="1" name=""/>
+        <p:cNvGrpSpPr/>
+        <p:nvPr/>
+      </p:nvGrpSpPr>
+      <p:grpSpPr/>
+      <p:sp>
+        <p:nvSpPr>
+          <p:cNvPr id="2" name="Rectangle 1"/>
+          <p:cNvSpPr/>
+          <p:nvPr/>
+        </p:nvSpPr>
+        <p:spPr>
+          <a:xfrm>
+            <a:off x="0" y="0"/>
+            <a:ext cx="12191695" cy="1143000"/>
+          </a:xfrm>
+          <a:prstGeom prst="rect">
+            <a:avLst/>
+          </a:prstGeom>
+          <a:solidFill>
+            <a:srgbClr val="0D3B66"/>
+          </a:solidFill>
+          <a:ln>
+            <a:noFill/>
+          </a:ln>
+        </p:spPr>
+        <p:style>
+          <a:lnRef idx="1">
+            <a:schemeClr val="accent1"/>
+          </a:lnRef>
+          <a:fillRef idx="3">
+            <a:schemeClr val="accent1"/>
+          </a:fillRef>
+          <a:effectRef idx="2">
+            <a:schemeClr val="accent1"/>
+          </a:effectRef>
+          <a:fontRef idx="minor">
+            <a:schemeClr val="lt1"/>
+          </a:fontRef>
+        </p:style>
+        <p:txBody>
+          <a:bodyPr rtlCol="0" anchor="ctr" wrap="square" lIns="548640"/>
+          <a:lstStyle/>
+          <a:p>
+            <a:pPr algn="ctr"/>
+            <a:r>
+              <a:rPr sz="3000" b="1">
+                <a:solidFill>
+                  <a:srgbClr val="FFFFFF"/>
+                </a:solidFill>
+              </a:rPr>
+              <a:t>Future Work</a:t>
+            </a:r>
+          </a:p>
+        </p:txBody>
+      </p:sp>
+      <p:sp>
+        <p:nvSpPr>
+          <p:cNvPr id="3" name="TextBox 2"/>
+          <p:cNvSpPr txBox="1"/>
+          <p:nvPr/>
+        </p:nvSpPr>
+        <p:spPr>
+          <a:xfrm>
+            <a:off x="822960" y="1554480"/>
+            <a:ext cx="10515600" cy="4937760"/>
+          </a:xfrm>
+          <a:prstGeom prst="rect">
+            <a:avLst/>
+          </a:prstGeom>
+          <a:noFill/>
+        </p:spPr>
+        <p:txBody>
+          <a:bodyPr wrap="square">
+            <a:spAutoFit/>
+          </a:bodyPr>
+          <a:lstStyle/>
+          <a:p>
+            <a:pPr>
+              <a:spcAft>
+                <a:spcPts val="1400"/>
+              </a:spcAft>
+            </a:pPr>
+            <a:r>
+              <a:rPr sz="2000" b="1">
+                <a:solidFill>
+                  <a:srgbClr val="EE6C4D"/>
+                </a:solidFill>
+              </a:rPr>
+              <a:t>▸  </a:t>
+            </a:r>
+            <a:r>
+              <a:rPr sz="2000">
+                <a:solidFill>
+                  <a:srgbClr val="1F2933"/>
+                </a:solidFill>
+              </a:rPr>
+              <a:t>SMS / email notifications on status changes.</a:t>
+            </a:r>
+          </a:p>
+          <a:p>
+            <a:pPr>
+              <a:spcAft>
+                <a:spcPts val="1400"/>
+              </a:spcAft>
+            </a:pPr>
+            <a:r>
+              <a:rPr sz="2000" b="1">
+                <a:solidFill>
+                  <a:srgbClr val="EE6C4D"/>
+                </a:solidFill>
+              </a:rPr>
+              <a:t>▸  </a:t>
+            </a:r>
+            <a:r>
+              <a:rPr sz="2000">
+                <a:solidFill>
+                  <a:srgbClr val="1F2933"/>
+                </a:solidFill>
+              </a:rPr>
+              <a:t>Cash-on-delivery settlement and merchant payouts.</a:t>
+            </a:r>
+          </a:p>
+          <a:p>
+            <a:pPr>
+              <a:spcAft>
+                <a:spcPts val="1400"/>
+              </a:spcAft>
+            </a:pPr>
+            <a:r>
+              <a:rPr sz="2000" b="1">
+                <a:solidFill>
+                  <a:srgbClr val="EE6C4D"/>
+                </a:solidFill>
+              </a:rPr>
+              <a:t>▸  </a:t>
+            </a:r>
+            <a:r>
+              <a:rPr sz="2000">
+                <a:solidFill>
+                  <a:srgbClr val="1F2933"/>
+                </a:solidFill>
+              </a:rPr>
+              <a:t>Live GPS tracking and a native courier mobile app.</a:t>
+            </a:r>
+          </a:p>
+          <a:p>
+            <a:pPr>
+              <a:spcAft>
+                <a:spcPts val="1400"/>
+              </a:spcAft>
+            </a:pPr>
+            <a:r>
+              <a:rPr sz="2000" b="1">
+                <a:solidFill>
+                  <a:srgbClr val="EE6C4D"/>
+                </a:solidFill>
+              </a:rPr>
+              <a:t>▸  </a:t>
+            </a:r>
+            <a:r>
+              <a:rPr sz="2000">
+                <a:solidFill>
+                  <a:srgbClr val="1F2933"/>
+                </a:solidFill>
+              </a:rPr>
+              <a:t>ML-driven demand forecasting and dynamic re-routing.</a:t>
+            </a:r>
+          </a:p>
+        </p:txBody>
+      </p:sp>
+    </p:spTree>
+  </p:cSld>
+  <p:clrMapOvr>
+    <a:masterClrMapping/>
+  </p:clrMapOvr>
+</p:sld>
+</file>
+
+<file path=ppt/slides/slide18.xml><?xml version="1.0" encoding="utf-8"?>
 <p:sld xmlns:a="http://schemas.openxmlformats.org/drawingml/2006/main" xmlns:p="http://schemas.openxmlformats.org/presentationml/2006/main" xmlns:r="http://schemas.openxmlformats.org/officeDocument/2006/relationships">
   <p:cSld>
     <p:bg>
@@ -5633,7 +6168,7 @@
                   <a:srgbClr val="1F2933"/>
                 </a:solidFill>
               </a:rPr>
-              <a:t>2) Nearest-neighbour + 2-opt sequence each route (the TSP).</a:t>
+              <a:t>2) A capacity-aware pass assigns parcels without overloading a vehicle.</a:t>
             </a:r>
           </a:p>
           <a:p>
@@ -5656,7 +6191,30 @@
                   <a:srgbClr val="1F2933"/>
                 </a:solidFill>
               </a:rPr>
-              <a:t>3) Optional OSMnx + Dijkstra draw real road paths; ETA from speed.</a:t>
+              <a:t>3) A selectable technique sequences each route (the TSP sub-problem).</a:t>
+            </a:r>
+          </a:p>
+          <a:p>
+            <a:pPr>
+              <a:spcAft>
+                <a:spcPts val="1400"/>
+              </a:spcAft>
+            </a:pPr>
+            <a:r>
+              <a:rPr sz="2000" b="1">
+                <a:solidFill>
+                  <a:srgbClr val="EE6C4D"/>
+                </a:solidFill>
+              </a:rPr>
+              <a:t>▸  </a:t>
+            </a:r>
+            <a:r>
+              <a:rPr sz="2000">
+                <a:solidFill>
+                  <a:srgbClr val="1F2933"/>
+                </a:solidFill>
+              </a:rPr>
+              <a:t>4) OSRM draws real road paths; ETA from distance, speed &amp; traffic.</a:t>
             </a:r>
           </a:p>
           <a:p>
@@ -5756,7 +6314,7 @@
                   <a:srgbClr val="FFFFFF"/>
                 </a:solidFill>
               </a:rPr>
-              <a:t>Shipment Lifecycle</a:t>
+              <a:t>Six Optimisation Techniques</a:t>
             </a:r>
           </a:p>
         </p:txBody>
@@ -5802,7 +6360,7 @@
                   <a:srgbClr val="1F2933"/>
                 </a:solidFill>
               </a:rPr>
-              <a:t>pending → at_warehouse → out_for_delivery → delivered.</a:t>
+              <a:t>FIFO — as received: the baseline to beat.</a:t>
             </a:r>
           </a:p>
           <a:p>
@@ -5825,7 +6383,7 @@
                   <a:srgbClr val="1F2933"/>
                 </a:solidFill>
               </a:rPr>
-              <a:t>Plus failed, returned and cancelled states.</a:t>
+              <a:t>Nearest Neighbour — fast greedy heuristic.</a:t>
             </a:r>
           </a:p>
           <a:p>
@@ -5848,7 +6406,7 @@
                   <a:srgbClr val="1F2933"/>
                 </a:solidFill>
               </a:rPr>
-              <a:t>Every change is recorded as an immutable event.</a:t>
+              <a:t>2-opt — local search removing crossing/expensive edges (default).</a:t>
             </a:r>
           </a:p>
           <a:p>
@@ -5871,7 +6429,53 @@
                   <a:srgbClr val="1F2933"/>
                 </a:solidFill>
               </a:rPr>
-              <a:t>The customer-facing timeline is built from these events.</a:t>
+              <a:t>Or-opt — adds segment relocation; highest quality.</a:t>
+            </a:r>
+          </a:p>
+          <a:p>
+            <a:pPr>
+              <a:spcAft>
+                <a:spcPts val="1400"/>
+              </a:spcAft>
+            </a:pPr>
+            <a:r>
+              <a:rPr sz="2000" b="1">
+                <a:solidFill>
+                  <a:srgbClr val="EE6C4D"/>
+                </a:solidFill>
+              </a:rPr>
+              <a:t>▸  </a:t>
+            </a:r>
+            <a:r>
+              <a:rPr sz="2000">
+                <a:solidFill>
+                  <a:srgbClr val="1F2933"/>
+                </a:solidFill>
+              </a:rPr>
+              <a:t>Christofides (NetworkX) — proven 1.5×-optimal guarantee for metric TSP.</a:t>
+            </a:r>
+          </a:p>
+          <a:p>
+            <a:pPr>
+              <a:spcAft>
+                <a:spcPts val="1400"/>
+              </a:spcAft>
+            </a:pPr>
+            <a:r>
+              <a:rPr sz="2000" b="1">
+                <a:solidFill>
+                  <a:srgbClr val="EE6C4D"/>
+                </a:solidFill>
+              </a:rPr>
+              <a:t>▸  </a:t>
+            </a:r>
+            <a:r>
+              <a:rPr sz="2000">
+                <a:solidFill>
+                  <a:srgbClr val="1F2933"/>
+                </a:solidFill>
+              </a:rPr>
+              <a:t>Simulated Annealing (NetworkX) — metaheuristic escaping local optima.</a:t>
             </a:r>
           </a:p>
         </p:txBody>

</xml_diff>

<commit_message>
Document the AI/ML suite across report, slides, user guide and README
- add a full 'Predictive Intelligence Layer' chapter to the generated report
  (ETA/late-risk, cross-validation & baselines, forecasting, NLP, neural router,
  personas, feedback/audit) and renumber engineering/conclusion
- add AI/ML slides to the presentation outline and deck generator (25 slides)
- add an AI/Data Science section to the user guide admin walkthrough
- README: note ML cross-validation, correct tech stack and architecture tree
</commit_message>
<xml_diff>
--- a/docs/presentation.pptx
+++ b/docs/presentation.pptx
@@ -23,6 +23,13 @@
     <p:sldId id="271" r:id="rId22"/>
     <p:sldId id="272" r:id="rId23"/>
     <p:sldId id="273" r:id="rId24"/>
+    <p:sldId id="274" r:id="rId25"/>
+    <p:sldId id="275" r:id="rId26"/>
+    <p:sldId id="276" r:id="rId27"/>
+    <p:sldId id="277" r:id="rId28"/>
+    <p:sldId id="278" r:id="rId29"/>
+    <p:sldId id="279" r:id="rId30"/>
+    <p:sldId id="280" r:id="rId31"/>
   </p:sldIdLst>
   <p:sldSz cx="12191695" cy="6858000" type="screen4x3"/>
   <p:notesSz cx="6858000" cy="9144000"/>
@@ -3647,7 +3654,7 @@
                   <a:srgbClr val="FFFFFF"/>
                 </a:solidFill>
               </a:rPr>
-              <a:t>Shipment Lifecycle</a:t>
+              <a:t>Predictive Intelligence Layer</a:t>
             </a:r>
           </a:p>
         </p:txBody>
@@ -3693,7 +3700,7 @@
                   <a:srgbClr val="1F2933"/>
                 </a:solidFill>
               </a:rPr>
-              <a:t>pending → at_warehouse → out_for_delivery → delivered.</a:t>
+              <a:t>Explainable ML on numpy / scikit-learn — no GPU, deploys on a free tier.</a:t>
             </a:r>
           </a:p>
           <a:p>
@@ -3716,7 +3723,7 @@
                   <a:srgbClr val="1F2933"/>
                 </a:solidFill>
               </a:rPr>
-              <a:t>Plus failed, returned and cancelled states.</a:t>
+              <a:t>Five slices: ETA &amp; forecasting, feedback/audit, NLP &amp; assistant, learning-to-route, personas.</a:t>
             </a:r>
           </a:p>
           <a:p>
@@ -3739,7 +3746,7 @@
                   <a:srgbClr val="1F2933"/>
                 </a:solidFill>
               </a:rPr>
-              <a:t>Every change is recorded as an immutable event.</a:t>
+              <a:t>Trained on a seeded, reproducible synthetic history (~5.8k deliveries / 180 days).</a:t>
             </a:r>
           </a:p>
           <a:p>
@@ -3762,7 +3769,7 @@
                   <a:srgbClr val="1F2933"/>
                 </a:solidFill>
               </a:rPr>
-              <a:t>The customer-facing timeline is built from these events.</a:t>
+              <a:t>Guiding principle: every prediction reports its reasoning.</a:t>
             </a:r>
           </a:p>
         </p:txBody>
@@ -3839,7 +3846,7 @@
                   <a:srgbClr val="FFFFFF"/>
                 </a:solidFill>
               </a:rPr>
-              <a:t>Difficult Choices &amp; Trade-offs</a:t>
+              <a:t>ETA &amp; Late-Risk + Validation</a:t>
             </a:r>
           </a:p>
         </p:txBody>
@@ -3885,7 +3892,7 @@
                   <a:srgbClr val="1F2933"/>
                 </a:solidFill>
               </a:rPr>
-              <a:t>SQLite vs PostgreSQL → support both via one DATABASE_URL.</a:t>
+              <a:t>Gradient-boosting models: drop-off time, pickup time, late-risk.</a:t>
             </a:r>
           </a:p>
           <a:p>
@@ -3908,7 +3915,7 @@
                   <a:srgbClr val="1F2933"/>
                 </a:solidFill>
               </a:rPr>
-              <a:t>Heavy ML libraries → made optional, never required.</a:t>
+              <a:t>Shared train/serve features; exact additive explanations per prediction.</a:t>
             </a:r>
           </a:p>
           <a:p>
@@ -3931,7 +3938,7 @@
                   <a:srgbClr val="1F2933"/>
                 </a:solidFill>
               </a:rPr>
-              <a:t>Global vs project .env → self-contained config (a real bug we fixed).</a:t>
+              <a:t>Validated with 5-fold CV vs naive baselines.</a:t>
             </a:r>
           </a:p>
           <a:p>
@@ -3954,30 +3961,7 @@
                   <a:srgbClr val="1F2933"/>
                 </a:solidFill>
               </a:rPr>
-              <a:t>Geocoding vs “drop a pin” → map pin + landmark text.</a:t>
-            </a:r>
-          </a:p>
-          <a:p>
-            <a:pPr>
-              <a:spcAft>
-                <a:spcPts val="1400"/>
-              </a:spcAft>
-            </a:pPr>
-            <a:r>
-              <a:rPr sz="2000" b="1">
-                <a:solidFill>
-                  <a:srgbClr val="EE6C4D"/>
-                </a:solidFill>
-              </a:rPr>
-              <a:t>▸  </a:t>
-            </a:r>
-            <a:r>
-              <a:rPr sz="2000">
-                <a:solidFill>
-                  <a:srgbClr val="1F2933"/>
-                </a:solidFill>
-              </a:rPr>
-              <a:t>SPA vs server-rendered → server-rendered, single stack.</a:t>
+              <a:t>Drop-off MAE 2.75±0.04 (72% better than mean); late-risk CV AUC 0.83.</a:t>
             </a:r>
           </a:p>
         </p:txBody>
@@ -4054,7 +4038,7 @@
                   <a:srgbClr val="FFFFFF"/>
                 </a:solidFill>
               </a:rPr>
-              <a:t>Security</a:t>
+              <a:t>Demand &amp; Cost Forecasting</a:t>
             </a:r>
           </a:p>
         </p:txBody>
@@ -4100,7 +4084,7 @@
                   <a:srgbClr val="1F2933"/>
                 </a:solidFill>
               </a:rPr>
-              <a:t>Passwords hashed with Werkzeug (PBKDF2).</a:t>
+              <a:t>White-box SeasonalTrendForecaster: trend + weekly seasonality + 95% band.</a:t>
             </a:r>
           </a:p>
           <a:p>
@@ -4123,7 +4107,7 @@
                   <a:srgbClr val="1F2933"/>
                 </a:solidFill>
               </a:rPr>
-              <a:t>CSRF protection on every browser form.</a:t>
+              <a:t>Rolling-origin (time-series) CV: orders MAPE ~16% vs ~18.5% seasonal-naive.</a:t>
             </a:r>
           </a:p>
           <a:p>
@@ -4146,30 +4130,7 @@
                   <a:srgbClr val="1F2933"/>
                 </a:solidFill>
               </a:rPr>
-              <a:t>Role-based access control via a decorator.</a:t>
-            </a:r>
-          </a:p>
-          <a:p>
-            <a:pPr>
-              <a:spcAft>
-                <a:spcPts val="1400"/>
-              </a:spcAft>
-            </a:pPr>
-            <a:r>
-              <a:rPr sz="2000" b="1">
-                <a:solidFill>
-                  <a:srgbClr val="EE6C4D"/>
-                </a:solidFill>
-              </a:rPr>
-              <a:t>▸  </a:t>
-            </a:r>
-            <a:r>
-              <a:rPr sz="2000">
-                <a:solidFill>
-                  <a:srgbClr val="1F2933"/>
-                </a:solidFill>
-              </a:rPr>
-              <a:t>Server-side validation and open-redirect protection.</a:t>
+              <a:t>Self-explaining: baseline level, growth/day, best/worst weekday, uncertainty.</a:t>
             </a:r>
           </a:p>
         </p:txBody>
@@ -4246,7 +4207,7 @@
                   <a:srgbClr val="FFFFFF"/>
                 </a:solidFill>
               </a:rPr>
-              <a:t>Live Demo Flow</a:t>
+              <a:t>Handling-Note NLP &amp; Assistant</a:t>
             </a:r>
           </a:p>
         </p:txBody>
@@ -4292,7 +4253,7 @@
                   <a:srgbClr val="1F2933"/>
                 </a:solidFill>
               </a:rPr>
-              <a:t>Merchant creates a shipment by dropping a pin on the map.</a:t>
+              <a:t>Hybrid tagger (regex lexicon + TF-IDF logistic regression), 10-tag taxonomy.</a:t>
             </a:r>
           </a:p>
           <a:p>
@@ -4315,7 +4276,7 @@
                   <a:srgbClr val="1F2933"/>
                 </a:solidFill>
               </a:rPr>
-              <a:t>Admin marks it At-Warehouse and runs the optimiser.</a:t>
+              <a:t>Extracts delivery time windows and target floor; per-tag token contributions.</a:t>
             </a:r>
           </a:p>
           <a:p>
@@ -4338,30 +4299,7 @@
                   <a:srgbClr val="1F2933"/>
                 </a:solidFill>
               </a:rPr>
-              <a:t>Courier sees the route, delivers, captures proof of delivery.</a:t>
-            </a:r>
-          </a:p>
-          <a:p>
-            <a:pPr>
-              <a:spcAft>
-                <a:spcPts val="1400"/>
-              </a:spcAft>
-            </a:pPr>
-            <a:r>
-              <a:rPr sz="2000" b="1">
-                <a:solidFill>
-                  <a:srgbClr val="EE6C4D"/>
-                </a:solidFill>
-              </a:rPr>
-              <a:t>▸  </a:t>
-            </a:r>
-            <a:r>
-              <a:rPr sz="2000">
-                <a:solidFill>
-                  <a:srgbClr val="1F2933"/>
-                </a:solidFill>
-              </a:rPr>
-              <a:t>Anyone tracks the parcel publicly by its number.</a:t>
+              <a:t>Assistant: natural-language Q&amp;A grounded in live data — every answer lists its sources.</a:t>
             </a:r>
           </a:p>
         </p:txBody>
@@ -4438,7 +4376,7 @@
                   <a:srgbClr val="FFFFFF"/>
                 </a:solidFill>
               </a:rPr>
-              <a:t>Testing &amp; Quality</a:t>
+              <a:t>Learning-to-Route (Neural Policy)</a:t>
             </a:r>
           </a:p>
         </p:txBody>
@@ -4484,7 +4422,7 @@
                   <a:srgbClr val="1F2933"/>
                 </a:solidFill>
               </a:rPr>
-              <a:t>End-to-end tests over the real create → optimise → deliver → track flow.</a:t>
+              <a:t>Pure-numpy pointer policy; REINFORCE with a greedy-rollout baseline.</a:t>
             </a:r>
           </a:p>
           <a:p>
@@ -4507,7 +4445,7 @@
                   <a:srgbClr val="1F2933"/>
                 </a:solidFill>
               </a:rPr>
-              <a:t>Role-protection tests ensure permissions hold.</a:t>
+              <a:t>Best-of-N rollouts: ~5% shorter than nearest-neighbour, ~2% off 2-opt.</a:t>
             </a:r>
           </a:p>
           <a:p>
@@ -4530,30 +4468,7 @@
                   <a:srgbClr val="1F2933"/>
                 </a:solidFill>
               </a:rPr>
-              <a:t>Optimiser test verifies routes are assigned and measured.</a:t>
-            </a:r>
-          </a:p>
-          <a:p>
-            <a:pPr>
-              <a:spcAft>
-                <a:spcPts val="1400"/>
-              </a:spcAft>
-            </a:pPr>
-            <a:r>
-              <a:rPr sz="2000" b="1">
-                <a:solidFill>
-                  <a:srgbClr val="EE6C4D"/>
-                </a:solidFill>
-              </a:rPr>
-              <a:t>▸  </a:t>
-            </a:r>
-            <a:r>
-              <a:rPr sz="2000">
-                <a:solidFill>
-                  <a:srgbClr val="1F2933"/>
-                </a:solidFill>
-              </a:rPr>
-              <a:t>All tests pass on the in-memory database.</a:t>
+              <a:t>Each pick reports its top feature reasons — a modern RL take on routing.</a:t>
             </a:r>
           </a:p>
         </p:txBody>
@@ -4630,7 +4545,7 @@
                   <a:srgbClr val="FFFFFF"/>
                 </a:solidFill>
               </a:rPr>
-              <a:t>Future Work</a:t>
+              <a:t>Courier-Behaviour Personas</a:t>
             </a:r>
           </a:p>
         </p:txBody>
@@ -4676,7 +4591,7 @@
                   <a:srgbClr val="1F2933"/>
                 </a:solidFill>
               </a:rPr>
-              <a:t>SMS / email notifications on status changes.</a:t>
+              <a:t>Mine GPS traces for stops → behavioural features → K-Means personas.</a:t>
             </a:r>
           </a:p>
           <a:p>
@@ -4699,7 +4614,7 @@
                   <a:srgbClr val="1F2933"/>
                 </a:solidFill>
               </a:rPr>
-              <a:t>Cash-on-delivery settlement and merchant payouts.</a:t>
+              <a:t>Ranked by productivity; evaluated with silhouette + adjusted Rand index.</a:t>
             </a:r>
           </a:p>
           <a:p>
@@ -4722,30 +4637,7 @@
                   <a:srgbClr val="1F2933"/>
                 </a:solidFill>
               </a:rPr>
-              <a:t>Live GPS tracking and a native courier mobile app.</a:t>
-            </a:r>
-          </a:p>
-          <a:p>
-            <a:pPr>
-              <a:spcAft>
-                <a:spcPts val="1400"/>
-              </a:spcAft>
-            </a:pPr>
-            <a:r>
-              <a:rPr sz="2000" b="1">
-                <a:solidFill>
-                  <a:srgbClr val="EE6C4D"/>
-                </a:solidFill>
-              </a:rPr>
-              <a:t>▸  </a:t>
-            </a:r>
-            <a:r>
-              <a:rPr sz="2000">
-                <a:solidFill>
-                  <a:srgbClr val="1F2933"/>
-                </a:solidFill>
-              </a:rPr>
-              <a:t>ML-driven demand forecasting and dynamic re-routing.</a:t>
+              <a:t>Honest caveat: the ground-truth archetypes are synthetic.</a:t>
             </a:r>
           </a:p>
         </p:txBody>
@@ -4759,6 +4651,1519 @@
 </file>
 
 <file path=ppt/slides/slide18.xml><?xml version="1.0" encoding="utf-8"?>
+<p:sld xmlns:a="http://schemas.openxmlformats.org/drawingml/2006/main" xmlns:p="http://schemas.openxmlformats.org/presentationml/2006/main" xmlns:r="http://schemas.openxmlformats.org/officeDocument/2006/relationships">
+  <p:cSld>
+    <p:bg>
+      <p:bgPr>
+        <a:solidFill>
+          <a:srgbClr val="F4F7FB"/>
+        </a:solidFill>
+        <a:effectLst/>
+      </p:bgPr>
+    </p:bg>
+    <p:spTree>
+      <p:nvGrpSpPr>
+        <p:cNvPr id="1" name=""/>
+        <p:cNvGrpSpPr/>
+        <p:nvPr/>
+      </p:nvGrpSpPr>
+      <p:grpSpPr/>
+      <p:sp>
+        <p:nvSpPr>
+          <p:cNvPr id="2" name="Rectangle 1"/>
+          <p:cNvSpPr/>
+          <p:nvPr/>
+        </p:nvSpPr>
+        <p:spPr>
+          <a:xfrm>
+            <a:off x="0" y="0"/>
+            <a:ext cx="12191695" cy="1143000"/>
+          </a:xfrm>
+          <a:prstGeom prst="rect">
+            <a:avLst/>
+          </a:prstGeom>
+          <a:solidFill>
+            <a:srgbClr val="0D3B66"/>
+          </a:solidFill>
+          <a:ln>
+            <a:noFill/>
+          </a:ln>
+        </p:spPr>
+        <p:style>
+          <a:lnRef idx="1">
+            <a:schemeClr val="accent1"/>
+          </a:lnRef>
+          <a:fillRef idx="3">
+            <a:schemeClr val="accent1"/>
+          </a:fillRef>
+          <a:effectRef idx="2">
+            <a:schemeClr val="accent1"/>
+          </a:effectRef>
+          <a:fontRef idx="minor">
+            <a:schemeClr val="lt1"/>
+          </a:fontRef>
+        </p:style>
+        <p:txBody>
+          <a:bodyPr rtlCol="0" anchor="ctr" wrap="square" lIns="548640"/>
+          <a:lstStyle/>
+          <a:p>
+            <a:pPr algn="ctr"/>
+            <a:r>
+              <a:rPr sz="3000" b="1">
+                <a:solidFill>
+                  <a:srgbClr val="FFFFFF"/>
+                </a:solidFill>
+              </a:rPr>
+              <a:t>Trust: Audit, GIS &amp; Drift</a:t>
+            </a:r>
+          </a:p>
+        </p:txBody>
+      </p:sp>
+      <p:sp>
+        <p:nvSpPr>
+          <p:cNvPr id="3" name="TextBox 2"/>
+          <p:cNvSpPr txBox="1"/>
+          <p:nvPr/>
+        </p:nvSpPr>
+        <p:spPr>
+          <a:xfrm>
+            <a:off x="822960" y="1554480"/>
+            <a:ext cx="10515600" cy="4937760"/>
+          </a:xfrm>
+          <a:prstGeom prst="rect">
+            <a:avLst/>
+          </a:prstGeom>
+          <a:noFill/>
+        </p:spPr>
+        <p:txBody>
+          <a:bodyPr wrap="square">
+            <a:spAutoFit/>
+          </a:bodyPr>
+          <a:lstStyle/>
+          <a:p>
+            <a:pPr>
+              <a:spcAft>
+                <a:spcPts val="1400"/>
+              </a:spcAft>
+            </a:pPr>
+            <a:r>
+              <a:rPr sz="2000" b="1">
+                <a:solidFill>
+                  <a:srgbClr val="EE6C4D"/>
+                </a:solidFill>
+              </a:rPr>
+              <a:t>▸  </a:t>
+            </a:r>
+            <a:r>
+              <a:rPr sz="2000">
+                <a:solidFill>
+                  <a:srgbClr val="1F2933"/>
+                </a:solidFill>
+              </a:rPr>
+              <a:t>SHA-256 hash-chained chain-of-custody — tamper-detectable handoffs.</a:t>
+            </a:r>
+          </a:p>
+          <a:p>
+            <a:pPr>
+              <a:spcAft>
+                <a:spcPts val="1400"/>
+              </a:spcAft>
+            </a:pPr>
+            <a:r>
+              <a:rPr sz="2000" b="1">
+                <a:solidFill>
+                  <a:srgbClr val="EE6C4D"/>
+                </a:solidFill>
+              </a:rPr>
+              <a:t>▸  </a:t>
+            </a:r>
+            <a:r>
+              <a:rPr sz="2000">
+                <a:solidFill>
+                  <a:srgbClr val="1F2933"/>
+                </a:solidFill>
+              </a:rPr>
+              <a:t>GIS geofence confirms delivery at the destination.</a:t>
+            </a:r>
+          </a:p>
+          <a:p>
+            <a:pPr>
+              <a:spcAft>
+                <a:spcPts val="1400"/>
+              </a:spcAft>
+            </a:pPr>
+            <a:r>
+              <a:rPr sz="2000" b="1">
+                <a:solidFill>
+                  <a:srgbClr val="EE6C4D"/>
+                </a:solidFill>
+              </a:rPr>
+              <a:t>▸  </a:t>
+            </a:r>
+            <a:r>
+              <a:rPr sz="2000">
+                <a:solidFill>
+                  <a:srgbClr val="1F2933"/>
+                </a:solidFill>
+              </a:rPr>
+              <a:t>Feedback loop: predicted-vs-actual logging, drift trigger, late-risk calibration.</a:t>
+            </a:r>
+          </a:p>
+        </p:txBody>
+      </p:sp>
+    </p:spTree>
+  </p:cSld>
+  <p:clrMapOvr>
+    <a:masterClrMapping/>
+  </p:clrMapOvr>
+</p:sld>
+</file>
+
+<file path=ppt/slides/slide19.xml><?xml version="1.0" encoding="utf-8"?>
+<p:sld xmlns:a="http://schemas.openxmlformats.org/drawingml/2006/main" xmlns:p="http://schemas.openxmlformats.org/presentationml/2006/main" xmlns:r="http://schemas.openxmlformats.org/officeDocument/2006/relationships">
+  <p:cSld>
+    <p:bg>
+      <p:bgPr>
+        <a:solidFill>
+          <a:srgbClr val="F4F7FB"/>
+        </a:solidFill>
+        <a:effectLst/>
+      </p:bgPr>
+    </p:bg>
+    <p:spTree>
+      <p:nvGrpSpPr>
+        <p:cNvPr id="1" name=""/>
+        <p:cNvGrpSpPr/>
+        <p:nvPr/>
+      </p:nvGrpSpPr>
+      <p:grpSpPr/>
+      <p:sp>
+        <p:nvSpPr>
+          <p:cNvPr id="2" name="Rectangle 1"/>
+          <p:cNvSpPr/>
+          <p:nvPr/>
+        </p:nvSpPr>
+        <p:spPr>
+          <a:xfrm>
+            <a:off x="0" y="0"/>
+            <a:ext cx="12191695" cy="1143000"/>
+          </a:xfrm>
+          <a:prstGeom prst="rect">
+            <a:avLst/>
+          </a:prstGeom>
+          <a:solidFill>
+            <a:srgbClr val="0D3B66"/>
+          </a:solidFill>
+          <a:ln>
+            <a:noFill/>
+          </a:ln>
+        </p:spPr>
+        <p:style>
+          <a:lnRef idx="1">
+            <a:schemeClr val="accent1"/>
+          </a:lnRef>
+          <a:fillRef idx="3">
+            <a:schemeClr val="accent1"/>
+          </a:fillRef>
+          <a:effectRef idx="2">
+            <a:schemeClr val="accent1"/>
+          </a:effectRef>
+          <a:fontRef idx="minor">
+            <a:schemeClr val="lt1"/>
+          </a:fontRef>
+        </p:style>
+        <p:txBody>
+          <a:bodyPr rtlCol="0" anchor="ctr" wrap="square" lIns="548640"/>
+          <a:lstStyle/>
+          <a:p>
+            <a:pPr algn="ctr"/>
+            <a:r>
+              <a:rPr sz="3000" b="1">
+                <a:solidFill>
+                  <a:srgbClr val="FFFFFF"/>
+                </a:solidFill>
+              </a:rPr>
+              <a:t>Shipment Lifecycle</a:t>
+            </a:r>
+          </a:p>
+        </p:txBody>
+      </p:sp>
+      <p:sp>
+        <p:nvSpPr>
+          <p:cNvPr id="3" name="TextBox 2"/>
+          <p:cNvSpPr txBox="1"/>
+          <p:nvPr/>
+        </p:nvSpPr>
+        <p:spPr>
+          <a:xfrm>
+            <a:off x="822960" y="1554480"/>
+            <a:ext cx="10515600" cy="4937760"/>
+          </a:xfrm>
+          <a:prstGeom prst="rect">
+            <a:avLst/>
+          </a:prstGeom>
+          <a:noFill/>
+        </p:spPr>
+        <p:txBody>
+          <a:bodyPr wrap="square">
+            <a:spAutoFit/>
+          </a:bodyPr>
+          <a:lstStyle/>
+          <a:p>
+            <a:pPr>
+              <a:spcAft>
+                <a:spcPts val="1400"/>
+              </a:spcAft>
+            </a:pPr>
+            <a:r>
+              <a:rPr sz="2000" b="1">
+                <a:solidFill>
+                  <a:srgbClr val="EE6C4D"/>
+                </a:solidFill>
+              </a:rPr>
+              <a:t>▸  </a:t>
+            </a:r>
+            <a:r>
+              <a:rPr sz="2000">
+                <a:solidFill>
+                  <a:srgbClr val="1F2933"/>
+                </a:solidFill>
+              </a:rPr>
+              <a:t>pending → at_warehouse → out_for_delivery → delivered.</a:t>
+            </a:r>
+          </a:p>
+          <a:p>
+            <a:pPr>
+              <a:spcAft>
+                <a:spcPts val="1400"/>
+              </a:spcAft>
+            </a:pPr>
+            <a:r>
+              <a:rPr sz="2000" b="1">
+                <a:solidFill>
+                  <a:srgbClr val="EE6C4D"/>
+                </a:solidFill>
+              </a:rPr>
+              <a:t>▸  </a:t>
+            </a:r>
+            <a:r>
+              <a:rPr sz="2000">
+                <a:solidFill>
+                  <a:srgbClr val="1F2933"/>
+                </a:solidFill>
+              </a:rPr>
+              <a:t>Plus failed, returned and cancelled states.</a:t>
+            </a:r>
+          </a:p>
+          <a:p>
+            <a:pPr>
+              <a:spcAft>
+                <a:spcPts val="1400"/>
+              </a:spcAft>
+            </a:pPr>
+            <a:r>
+              <a:rPr sz="2000" b="1">
+                <a:solidFill>
+                  <a:srgbClr val="EE6C4D"/>
+                </a:solidFill>
+              </a:rPr>
+              <a:t>▸  </a:t>
+            </a:r>
+            <a:r>
+              <a:rPr sz="2000">
+                <a:solidFill>
+                  <a:srgbClr val="1F2933"/>
+                </a:solidFill>
+              </a:rPr>
+              <a:t>Every change is recorded as an immutable event.</a:t>
+            </a:r>
+          </a:p>
+          <a:p>
+            <a:pPr>
+              <a:spcAft>
+                <a:spcPts val="1400"/>
+              </a:spcAft>
+            </a:pPr>
+            <a:r>
+              <a:rPr sz="2000" b="1">
+                <a:solidFill>
+                  <a:srgbClr val="EE6C4D"/>
+                </a:solidFill>
+              </a:rPr>
+              <a:t>▸  </a:t>
+            </a:r>
+            <a:r>
+              <a:rPr sz="2000">
+                <a:solidFill>
+                  <a:srgbClr val="1F2933"/>
+                </a:solidFill>
+              </a:rPr>
+              <a:t>The customer-facing timeline is built from these events.</a:t>
+            </a:r>
+          </a:p>
+        </p:txBody>
+      </p:sp>
+    </p:spTree>
+  </p:cSld>
+  <p:clrMapOvr>
+    <a:masterClrMapping/>
+  </p:clrMapOvr>
+</p:sld>
+</file>
+
+<file path=ppt/slides/slide2.xml><?xml version="1.0" encoding="utf-8"?>
+<p:sld xmlns:a="http://schemas.openxmlformats.org/drawingml/2006/main" xmlns:p="http://schemas.openxmlformats.org/presentationml/2006/main" xmlns:r="http://schemas.openxmlformats.org/officeDocument/2006/relationships">
+  <p:cSld>
+    <p:bg>
+      <p:bgPr>
+        <a:solidFill>
+          <a:srgbClr val="F4F7FB"/>
+        </a:solidFill>
+        <a:effectLst/>
+      </p:bgPr>
+    </p:bg>
+    <p:spTree>
+      <p:nvGrpSpPr>
+        <p:cNvPr id="1" name=""/>
+        <p:cNvGrpSpPr/>
+        <p:nvPr/>
+      </p:nvGrpSpPr>
+      <p:grpSpPr/>
+      <p:sp>
+        <p:nvSpPr>
+          <p:cNvPr id="2" name="Rectangle 1"/>
+          <p:cNvSpPr/>
+          <p:nvPr/>
+        </p:nvSpPr>
+        <p:spPr>
+          <a:xfrm>
+            <a:off x="0" y="0"/>
+            <a:ext cx="12191695" cy="1143000"/>
+          </a:xfrm>
+          <a:prstGeom prst="rect">
+            <a:avLst/>
+          </a:prstGeom>
+          <a:solidFill>
+            <a:srgbClr val="0D3B66"/>
+          </a:solidFill>
+          <a:ln>
+            <a:noFill/>
+          </a:ln>
+        </p:spPr>
+        <p:style>
+          <a:lnRef idx="1">
+            <a:schemeClr val="accent1"/>
+          </a:lnRef>
+          <a:fillRef idx="3">
+            <a:schemeClr val="accent1"/>
+          </a:fillRef>
+          <a:effectRef idx="2">
+            <a:schemeClr val="accent1"/>
+          </a:effectRef>
+          <a:fontRef idx="minor">
+            <a:schemeClr val="lt1"/>
+          </a:fontRef>
+        </p:style>
+        <p:txBody>
+          <a:bodyPr rtlCol="0" anchor="ctr" wrap="square" lIns="548640"/>
+          <a:lstStyle/>
+          <a:p>
+            <a:pPr algn="ctr"/>
+            <a:r>
+              <a:rPr sz="3000" b="1">
+                <a:solidFill>
+                  <a:srgbClr val="FFFFFF"/>
+                </a:solidFill>
+              </a:rPr>
+              <a:t>The Problem</a:t>
+            </a:r>
+          </a:p>
+        </p:txBody>
+      </p:sp>
+      <p:sp>
+        <p:nvSpPr>
+          <p:cNvPr id="3" name="TextBox 2"/>
+          <p:cNvSpPr txBox="1"/>
+          <p:nvPr/>
+        </p:nvSpPr>
+        <p:spPr>
+          <a:xfrm>
+            <a:off x="822960" y="1554480"/>
+            <a:ext cx="10515600" cy="4937760"/>
+          </a:xfrm>
+          <a:prstGeom prst="rect">
+            <a:avLst/>
+          </a:prstGeom>
+          <a:noFill/>
+        </p:spPr>
+        <p:txBody>
+          <a:bodyPr wrap="square">
+            <a:spAutoFit/>
+          </a:bodyPr>
+          <a:lstStyle/>
+          <a:p>
+            <a:pPr>
+              <a:spcAft>
+                <a:spcPts val="1400"/>
+              </a:spcAft>
+            </a:pPr>
+            <a:r>
+              <a:rPr sz="2000" b="1">
+                <a:solidFill>
+                  <a:srgbClr val="EE6C4D"/>
+                </a:solidFill>
+              </a:rPr>
+              <a:t>▸  </a:t>
+            </a:r>
+            <a:r>
+              <a:rPr sz="2000">
+                <a:solidFill>
+                  <a:srgbClr val="1F2933"/>
+                </a:solidFill>
+              </a:rPr>
+              <a:t>E-commerce is booming; last-mile delivery is the bottleneck.</a:t>
+            </a:r>
+          </a:p>
+          <a:p>
+            <a:pPr>
+              <a:spcAft>
+                <a:spcPts val="1400"/>
+              </a:spcAft>
+            </a:pPr>
+            <a:r>
+              <a:rPr sz="2000" b="1">
+                <a:solidFill>
+                  <a:srgbClr val="EE6C4D"/>
+                </a:solidFill>
+              </a:rPr>
+              <a:t>▸  </a:t>
+            </a:r>
+            <a:r>
+              <a:rPr sz="2000">
+                <a:solidFill>
+                  <a:srgbClr val="1F2933"/>
+                </a:solidFill>
+              </a:rPr>
+              <a:t>Manual courier dispatch is slow, uneven and error-prone.</a:t>
+            </a:r>
+          </a:p>
+          <a:p>
+            <a:pPr>
+              <a:spcAft>
+                <a:spcPts val="1400"/>
+              </a:spcAft>
+            </a:pPr>
+            <a:r>
+              <a:rPr sz="2000" b="1">
+                <a:solidFill>
+                  <a:srgbClr val="EE6C4D"/>
+                </a:solidFill>
+              </a:rPr>
+              <a:t>▸  </a:t>
+            </a:r>
+            <a:r>
+              <a:rPr sz="2000">
+                <a:solidFill>
+                  <a:srgbClr val="1F2933"/>
+                </a:solidFill>
+              </a:rPr>
+              <a:t>Customers expect real-time visibility: “where is my parcel?”</a:t>
+            </a:r>
+          </a:p>
+          <a:p>
+            <a:pPr>
+              <a:spcAft>
+                <a:spcPts val="1400"/>
+              </a:spcAft>
+            </a:pPr>
+            <a:r>
+              <a:rPr sz="2000" b="1">
+                <a:solidFill>
+                  <a:srgbClr val="EE6C4D"/>
+                </a:solidFill>
+              </a:rPr>
+              <a:t>▸  </a:t>
+            </a:r>
+            <a:r>
+              <a:rPr sz="2000">
+                <a:solidFill>
+                  <a:srgbClr val="1F2933"/>
+                </a:solidFill>
+              </a:rPr>
+              <a:t>Operations teams lack tools to plan and monitor the fleet.</a:t>
+            </a:r>
+          </a:p>
+        </p:txBody>
+      </p:sp>
+    </p:spTree>
+  </p:cSld>
+  <p:clrMapOvr>
+    <a:masterClrMapping/>
+  </p:clrMapOvr>
+</p:sld>
+</file>
+
+<file path=ppt/slides/slide20.xml><?xml version="1.0" encoding="utf-8"?>
+<p:sld xmlns:a="http://schemas.openxmlformats.org/drawingml/2006/main" xmlns:p="http://schemas.openxmlformats.org/presentationml/2006/main" xmlns:r="http://schemas.openxmlformats.org/officeDocument/2006/relationships">
+  <p:cSld>
+    <p:bg>
+      <p:bgPr>
+        <a:solidFill>
+          <a:srgbClr val="F4F7FB"/>
+        </a:solidFill>
+        <a:effectLst/>
+      </p:bgPr>
+    </p:bg>
+    <p:spTree>
+      <p:nvGrpSpPr>
+        <p:cNvPr id="1" name=""/>
+        <p:cNvGrpSpPr/>
+        <p:nvPr/>
+      </p:nvGrpSpPr>
+      <p:grpSpPr/>
+      <p:sp>
+        <p:nvSpPr>
+          <p:cNvPr id="2" name="Rectangle 1"/>
+          <p:cNvSpPr/>
+          <p:nvPr/>
+        </p:nvSpPr>
+        <p:spPr>
+          <a:xfrm>
+            <a:off x="0" y="0"/>
+            <a:ext cx="12191695" cy="1143000"/>
+          </a:xfrm>
+          <a:prstGeom prst="rect">
+            <a:avLst/>
+          </a:prstGeom>
+          <a:solidFill>
+            <a:srgbClr val="0D3B66"/>
+          </a:solidFill>
+          <a:ln>
+            <a:noFill/>
+          </a:ln>
+        </p:spPr>
+        <p:style>
+          <a:lnRef idx="1">
+            <a:schemeClr val="accent1"/>
+          </a:lnRef>
+          <a:fillRef idx="3">
+            <a:schemeClr val="accent1"/>
+          </a:fillRef>
+          <a:effectRef idx="2">
+            <a:schemeClr val="accent1"/>
+          </a:effectRef>
+          <a:fontRef idx="minor">
+            <a:schemeClr val="lt1"/>
+          </a:fontRef>
+        </p:style>
+        <p:txBody>
+          <a:bodyPr rtlCol="0" anchor="ctr" wrap="square" lIns="548640"/>
+          <a:lstStyle/>
+          <a:p>
+            <a:pPr algn="ctr"/>
+            <a:r>
+              <a:rPr sz="3000" b="1">
+                <a:solidFill>
+                  <a:srgbClr val="FFFFFF"/>
+                </a:solidFill>
+              </a:rPr>
+              <a:t>Difficult Choices &amp; Trade-offs</a:t>
+            </a:r>
+          </a:p>
+        </p:txBody>
+      </p:sp>
+      <p:sp>
+        <p:nvSpPr>
+          <p:cNvPr id="3" name="TextBox 2"/>
+          <p:cNvSpPr txBox="1"/>
+          <p:nvPr/>
+        </p:nvSpPr>
+        <p:spPr>
+          <a:xfrm>
+            <a:off x="822960" y="1554480"/>
+            <a:ext cx="10515600" cy="4937760"/>
+          </a:xfrm>
+          <a:prstGeom prst="rect">
+            <a:avLst/>
+          </a:prstGeom>
+          <a:noFill/>
+        </p:spPr>
+        <p:txBody>
+          <a:bodyPr wrap="square">
+            <a:spAutoFit/>
+          </a:bodyPr>
+          <a:lstStyle/>
+          <a:p>
+            <a:pPr>
+              <a:spcAft>
+                <a:spcPts val="1400"/>
+              </a:spcAft>
+            </a:pPr>
+            <a:r>
+              <a:rPr sz="2000" b="1">
+                <a:solidFill>
+                  <a:srgbClr val="EE6C4D"/>
+                </a:solidFill>
+              </a:rPr>
+              <a:t>▸  </a:t>
+            </a:r>
+            <a:r>
+              <a:rPr sz="2000">
+                <a:solidFill>
+                  <a:srgbClr val="1F2933"/>
+                </a:solidFill>
+              </a:rPr>
+              <a:t>SQLite vs PostgreSQL → support both via one DATABASE_URL.</a:t>
+            </a:r>
+          </a:p>
+          <a:p>
+            <a:pPr>
+              <a:spcAft>
+                <a:spcPts val="1400"/>
+              </a:spcAft>
+            </a:pPr>
+            <a:r>
+              <a:rPr sz="2000" b="1">
+                <a:solidFill>
+                  <a:srgbClr val="EE6C4D"/>
+                </a:solidFill>
+              </a:rPr>
+              <a:t>▸  </a:t>
+            </a:r>
+            <a:r>
+              <a:rPr sz="2000">
+                <a:solidFill>
+                  <a:srgbClr val="1F2933"/>
+                </a:solidFill>
+              </a:rPr>
+              <a:t>Heavy ML libraries → optional/light (no torch); models train in seconds.</a:t>
+            </a:r>
+          </a:p>
+          <a:p>
+            <a:pPr>
+              <a:spcAft>
+                <a:spcPts val="1400"/>
+              </a:spcAft>
+            </a:pPr>
+            <a:r>
+              <a:rPr sz="2000" b="1">
+                <a:solidFill>
+                  <a:srgbClr val="EE6C4D"/>
+                </a:solidFill>
+              </a:rPr>
+              <a:t>▸  </a:t>
+            </a:r>
+            <a:r>
+              <a:rPr sz="2000">
+                <a:solidFill>
+                  <a:srgbClr val="1F2933"/>
+                </a:solidFill>
+              </a:rPr>
+              <a:t>Synthetic data → reproducible, honestly labelled, validated with CV + baselines.</a:t>
+            </a:r>
+          </a:p>
+          <a:p>
+            <a:pPr>
+              <a:spcAft>
+                <a:spcPts val="1400"/>
+              </a:spcAft>
+            </a:pPr>
+            <a:r>
+              <a:rPr sz="2000" b="1">
+                <a:solidFill>
+                  <a:srgbClr val="EE6C4D"/>
+                </a:solidFill>
+              </a:rPr>
+              <a:t>▸  </a:t>
+            </a:r>
+            <a:r>
+              <a:rPr sz="2000">
+                <a:solidFill>
+                  <a:srgbClr val="1F2933"/>
+                </a:solidFill>
+              </a:rPr>
+              <a:t>SPA vs server-rendered → server-rendered, single stack.</a:t>
+            </a:r>
+          </a:p>
+        </p:txBody>
+      </p:sp>
+    </p:spTree>
+  </p:cSld>
+  <p:clrMapOvr>
+    <a:masterClrMapping/>
+  </p:clrMapOvr>
+</p:sld>
+</file>
+
+<file path=ppt/slides/slide21.xml><?xml version="1.0" encoding="utf-8"?>
+<p:sld xmlns:a="http://schemas.openxmlformats.org/drawingml/2006/main" xmlns:p="http://schemas.openxmlformats.org/presentationml/2006/main" xmlns:r="http://schemas.openxmlformats.org/officeDocument/2006/relationships">
+  <p:cSld>
+    <p:bg>
+      <p:bgPr>
+        <a:solidFill>
+          <a:srgbClr val="F4F7FB"/>
+        </a:solidFill>
+        <a:effectLst/>
+      </p:bgPr>
+    </p:bg>
+    <p:spTree>
+      <p:nvGrpSpPr>
+        <p:cNvPr id="1" name=""/>
+        <p:cNvGrpSpPr/>
+        <p:nvPr/>
+      </p:nvGrpSpPr>
+      <p:grpSpPr/>
+      <p:sp>
+        <p:nvSpPr>
+          <p:cNvPr id="2" name="Rectangle 1"/>
+          <p:cNvSpPr/>
+          <p:nvPr/>
+        </p:nvSpPr>
+        <p:spPr>
+          <a:xfrm>
+            <a:off x="0" y="0"/>
+            <a:ext cx="12191695" cy="1143000"/>
+          </a:xfrm>
+          <a:prstGeom prst="rect">
+            <a:avLst/>
+          </a:prstGeom>
+          <a:solidFill>
+            <a:srgbClr val="0D3B66"/>
+          </a:solidFill>
+          <a:ln>
+            <a:noFill/>
+          </a:ln>
+        </p:spPr>
+        <p:style>
+          <a:lnRef idx="1">
+            <a:schemeClr val="accent1"/>
+          </a:lnRef>
+          <a:fillRef idx="3">
+            <a:schemeClr val="accent1"/>
+          </a:fillRef>
+          <a:effectRef idx="2">
+            <a:schemeClr val="accent1"/>
+          </a:effectRef>
+          <a:fontRef idx="minor">
+            <a:schemeClr val="lt1"/>
+          </a:fontRef>
+        </p:style>
+        <p:txBody>
+          <a:bodyPr rtlCol="0" anchor="ctr" wrap="square" lIns="548640"/>
+          <a:lstStyle/>
+          <a:p>
+            <a:pPr algn="ctr"/>
+            <a:r>
+              <a:rPr sz="3000" b="1">
+                <a:solidFill>
+                  <a:srgbClr val="FFFFFF"/>
+                </a:solidFill>
+              </a:rPr>
+              <a:t>Security</a:t>
+            </a:r>
+          </a:p>
+        </p:txBody>
+      </p:sp>
+      <p:sp>
+        <p:nvSpPr>
+          <p:cNvPr id="3" name="TextBox 2"/>
+          <p:cNvSpPr txBox="1"/>
+          <p:nvPr/>
+        </p:nvSpPr>
+        <p:spPr>
+          <a:xfrm>
+            <a:off x="822960" y="1554480"/>
+            <a:ext cx="10515600" cy="4937760"/>
+          </a:xfrm>
+          <a:prstGeom prst="rect">
+            <a:avLst/>
+          </a:prstGeom>
+          <a:noFill/>
+        </p:spPr>
+        <p:txBody>
+          <a:bodyPr wrap="square">
+            <a:spAutoFit/>
+          </a:bodyPr>
+          <a:lstStyle/>
+          <a:p>
+            <a:pPr>
+              <a:spcAft>
+                <a:spcPts val="1400"/>
+              </a:spcAft>
+            </a:pPr>
+            <a:r>
+              <a:rPr sz="2000" b="1">
+                <a:solidFill>
+                  <a:srgbClr val="EE6C4D"/>
+                </a:solidFill>
+              </a:rPr>
+              <a:t>▸  </a:t>
+            </a:r>
+            <a:r>
+              <a:rPr sz="2000">
+                <a:solidFill>
+                  <a:srgbClr val="1F2933"/>
+                </a:solidFill>
+              </a:rPr>
+              <a:t>Passwords hashed with Werkzeug (PBKDF2).</a:t>
+            </a:r>
+          </a:p>
+          <a:p>
+            <a:pPr>
+              <a:spcAft>
+                <a:spcPts val="1400"/>
+              </a:spcAft>
+            </a:pPr>
+            <a:r>
+              <a:rPr sz="2000" b="1">
+                <a:solidFill>
+                  <a:srgbClr val="EE6C4D"/>
+                </a:solidFill>
+              </a:rPr>
+              <a:t>▸  </a:t>
+            </a:r>
+            <a:r>
+              <a:rPr sz="2000">
+                <a:solidFill>
+                  <a:srgbClr val="1F2933"/>
+                </a:solidFill>
+              </a:rPr>
+              <a:t>CSRF protection on every browser form.</a:t>
+            </a:r>
+          </a:p>
+          <a:p>
+            <a:pPr>
+              <a:spcAft>
+                <a:spcPts val="1400"/>
+              </a:spcAft>
+            </a:pPr>
+            <a:r>
+              <a:rPr sz="2000" b="1">
+                <a:solidFill>
+                  <a:srgbClr val="EE6C4D"/>
+                </a:solidFill>
+              </a:rPr>
+              <a:t>▸  </a:t>
+            </a:r>
+            <a:r>
+              <a:rPr sz="2000">
+                <a:solidFill>
+                  <a:srgbClr val="1F2933"/>
+                </a:solidFill>
+              </a:rPr>
+              <a:t>Role-based access control via a decorator.</a:t>
+            </a:r>
+          </a:p>
+          <a:p>
+            <a:pPr>
+              <a:spcAft>
+                <a:spcPts val="1400"/>
+              </a:spcAft>
+            </a:pPr>
+            <a:r>
+              <a:rPr sz="2000" b="1">
+                <a:solidFill>
+                  <a:srgbClr val="EE6C4D"/>
+                </a:solidFill>
+              </a:rPr>
+              <a:t>▸  </a:t>
+            </a:r>
+            <a:r>
+              <a:rPr sz="2000">
+                <a:solidFill>
+                  <a:srgbClr val="1F2933"/>
+                </a:solidFill>
+              </a:rPr>
+              <a:t>Server-side validation and open-redirect protection.</a:t>
+            </a:r>
+          </a:p>
+        </p:txBody>
+      </p:sp>
+    </p:spTree>
+  </p:cSld>
+  <p:clrMapOvr>
+    <a:masterClrMapping/>
+  </p:clrMapOvr>
+</p:sld>
+</file>
+
+<file path=ppt/slides/slide22.xml><?xml version="1.0" encoding="utf-8"?>
+<p:sld xmlns:a="http://schemas.openxmlformats.org/drawingml/2006/main" xmlns:p="http://schemas.openxmlformats.org/presentationml/2006/main" xmlns:r="http://schemas.openxmlformats.org/officeDocument/2006/relationships">
+  <p:cSld>
+    <p:bg>
+      <p:bgPr>
+        <a:solidFill>
+          <a:srgbClr val="F4F7FB"/>
+        </a:solidFill>
+        <a:effectLst/>
+      </p:bgPr>
+    </p:bg>
+    <p:spTree>
+      <p:nvGrpSpPr>
+        <p:cNvPr id="1" name=""/>
+        <p:cNvGrpSpPr/>
+        <p:nvPr/>
+      </p:nvGrpSpPr>
+      <p:grpSpPr/>
+      <p:sp>
+        <p:nvSpPr>
+          <p:cNvPr id="2" name="Rectangle 1"/>
+          <p:cNvSpPr/>
+          <p:nvPr/>
+        </p:nvSpPr>
+        <p:spPr>
+          <a:xfrm>
+            <a:off x="0" y="0"/>
+            <a:ext cx="12191695" cy="1143000"/>
+          </a:xfrm>
+          <a:prstGeom prst="rect">
+            <a:avLst/>
+          </a:prstGeom>
+          <a:solidFill>
+            <a:srgbClr val="0D3B66"/>
+          </a:solidFill>
+          <a:ln>
+            <a:noFill/>
+          </a:ln>
+        </p:spPr>
+        <p:style>
+          <a:lnRef idx="1">
+            <a:schemeClr val="accent1"/>
+          </a:lnRef>
+          <a:fillRef idx="3">
+            <a:schemeClr val="accent1"/>
+          </a:fillRef>
+          <a:effectRef idx="2">
+            <a:schemeClr val="accent1"/>
+          </a:effectRef>
+          <a:fontRef idx="minor">
+            <a:schemeClr val="lt1"/>
+          </a:fontRef>
+        </p:style>
+        <p:txBody>
+          <a:bodyPr rtlCol="0" anchor="ctr" wrap="square" lIns="548640"/>
+          <a:lstStyle/>
+          <a:p>
+            <a:pPr algn="ctr"/>
+            <a:r>
+              <a:rPr sz="3000" b="1">
+                <a:solidFill>
+                  <a:srgbClr val="FFFFFF"/>
+                </a:solidFill>
+              </a:rPr>
+              <a:t>Live Demo Flow</a:t>
+            </a:r>
+          </a:p>
+        </p:txBody>
+      </p:sp>
+      <p:sp>
+        <p:nvSpPr>
+          <p:cNvPr id="3" name="TextBox 2"/>
+          <p:cNvSpPr txBox="1"/>
+          <p:nvPr/>
+        </p:nvSpPr>
+        <p:spPr>
+          <a:xfrm>
+            <a:off x="822960" y="1554480"/>
+            <a:ext cx="10515600" cy="4937760"/>
+          </a:xfrm>
+          <a:prstGeom prst="rect">
+            <a:avLst/>
+          </a:prstGeom>
+          <a:noFill/>
+        </p:spPr>
+        <p:txBody>
+          <a:bodyPr wrap="square">
+            <a:spAutoFit/>
+          </a:bodyPr>
+          <a:lstStyle/>
+          <a:p>
+            <a:pPr>
+              <a:spcAft>
+                <a:spcPts val="1400"/>
+              </a:spcAft>
+            </a:pPr>
+            <a:r>
+              <a:rPr sz="2000" b="1">
+                <a:solidFill>
+                  <a:srgbClr val="EE6C4D"/>
+                </a:solidFill>
+              </a:rPr>
+              <a:t>▸  </a:t>
+            </a:r>
+            <a:r>
+              <a:rPr sz="2000">
+                <a:solidFill>
+                  <a:srgbClr val="1F2933"/>
+                </a:solidFill>
+              </a:rPr>
+              <a:t>Merchant creates a shipment by dropping a pin on the map.</a:t>
+            </a:r>
+          </a:p>
+          <a:p>
+            <a:pPr>
+              <a:spcAft>
+                <a:spcPts val="1400"/>
+              </a:spcAft>
+            </a:pPr>
+            <a:r>
+              <a:rPr sz="2000" b="1">
+                <a:solidFill>
+                  <a:srgbClr val="EE6C4D"/>
+                </a:solidFill>
+              </a:rPr>
+              <a:t>▸  </a:t>
+            </a:r>
+            <a:r>
+              <a:rPr sz="2000">
+                <a:solidFill>
+                  <a:srgbClr val="1F2933"/>
+                </a:solidFill>
+              </a:rPr>
+              <a:t>Admin marks it At-Warehouse and runs the optimiser.</a:t>
+            </a:r>
+          </a:p>
+          <a:p>
+            <a:pPr>
+              <a:spcAft>
+                <a:spcPts val="1400"/>
+              </a:spcAft>
+            </a:pPr>
+            <a:r>
+              <a:rPr sz="2000" b="1">
+                <a:solidFill>
+                  <a:srgbClr val="EE6C4D"/>
+                </a:solidFill>
+              </a:rPr>
+              <a:t>▸  </a:t>
+            </a:r>
+            <a:r>
+              <a:rPr sz="2000">
+                <a:solidFill>
+                  <a:srgbClr val="1F2933"/>
+                </a:solidFill>
+              </a:rPr>
+              <a:t>Courier sees the route, delivers, captures proof of delivery.</a:t>
+            </a:r>
+          </a:p>
+          <a:p>
+            <a:pPr>
+              <a:spcAft>
+                <a:spcPts val="1400"/>
+              </a:spcAft>
+            </a:pPr>
+            <a:r>
+              <a:rPr sz="2000" b="1">
+                <a:solidFill>
+                  <a:srgbClr val="EE6C4D"/>
+                </a:solidFill>
+              </a:rPr>
+              <a:t>▸  </a:t>
+            </a:r>
+            <a:r>
+              <a:rPr sz="2000">
+                <a:solidFill>
+                  <a:srgbClr val="1F2933"/>
+                </a:solidFill>
+              </a:rPr>
+              <a:t>Anyone tracks the parcel publicly; admin explores the AI dashboards.</a:t>
+            </a:r>
+          </a:p>
+        </p:txBody>
+      </p:sp>
+    </p:spTree>
+  </p:cSld>
+  <p:clrMapOvr>
+    <a:masterClrMapping/>
+  </p:clrMapOvr>
+</p:sld>
+</file>
+
+<file path=ppt/slides/slide23.xml><?xml version="1.0" encoding="utf-8"?>
+<p:sld xmlns:a="http://schemas.openxmlformats.org/drawingml/2006/main" xmlns:p="http://schemas.openxmlformats.org/presentationml/2006/main" xmlns:r="http://schemas.openxmlformats.org/officeDocument/2006/relationships">
+  <p:cSld>
+    <p:bg>
+      <p:bgPr>
+        <a:solidFill>
+          <a:srgbClr val="F4F7FB"/>
+        </a:solidFill>
+        <a:effectLst/>
+      </p:bgPr>
+    </p:bg>
+    <p:spTree>
+      <p:nvGrpSpPr>
+        <p:cNvPr id="1" name=""/>
+        <p:cNvGrpSpPr/>
+        <p:nvPr/>
+      </p:nvGrpSpPr>
+      <p:grpSpPr/>
+      <p:sp>
+        <p:nvSpPr>
+          <p:cNvPr id="2" name="Rectangle 1"/>
+          <p:cNvSpPr/>
+          <p:nvPr/>
+        </p:nvSpPr>
+        <p:spPr>
+          <a:xfrm>
+            <a:off x="0" y="0"/>
+            <a:ext cx="12191695" cy="1143000"/>
+          </a:xfrm>
+          <a:prstGeom prst="rect">
+            <a:avLst/>
+          </a:prstGeom>
+          <a:solidFill>
+            <a:srgbClr val="0D3B66"/>
+          </a:solidFill>
+          <a:ln>
+            <a:noFill/>
+          </a:ln>
+        </p:spPr>
+        <p:style>
+          <a:lnRef idx="1">
+            <a:schemeClr val="accent1"/>
+          </a:lnRef>
+          <a:fillRef idx="3">
+            <a:schemeClr val="accent1"/>
+          </a:fillRef>
+          <a:effectRef idx="2">
+            <a:schemeClr val="accent1"/>
+          </a:effectRef>
+          <a:fontRef idx="minor">
+            <a:schemeClr val="lt1"/>
+          </a:fontRef>
+        </p:style>
+        <p:txBody>
+          <a:bodyPr rtlCol="0" anchor="ctr" wrap="square" lIns="548640"/>
+          <a:lstStyle/>
+          <a:p>
+            <a:pPr algn="ctr"/>
+            <a:r>
+              <a:rPr sz="3000" b="1">
+                <a:solidFill>
+                  <a:srgbClr val="FFFFFF"/>
+                </a:solidFill>
+              </a:rPr>
+              <a:t>Testing &amp; Quality</a:t>
+            </a:r>
+          </a:p>
+        </p:txBody>
+      </p:sp>
+      <p:sp>
+        <p:nvSpPr>
+          <p:cNvPr id="3" name="TextBox 2"/>
+          <p:cNvSpPr txBox="1"/>
+          <p:nvPr/>
+        </p:nvSpPr>
+        <p:spPr>
+          <a:xfrm>
+            <a:off x="822960" y="1554480"/>
+            <a:ext cx="10515600" cy="4937760"/>
+          </a:xfrm>
+          <a:prstGeom prst="rect">
+            <a:avLst/>
+          </a:prstGeom>
+          <a:noFill/>
+        </p:spPr>
+        <p:txBody>
+          <a:bodyPr wrap="square">
+            <a:spAutoFit/>
+          </a:bodyPr>
+          <a:lstStyle/>
+          <a:p>
+            <a:pPr>
+              <a:spcAft>
+                <a:spcPts val="1400"/>
+              </a:spcAft>
+            </a:pPr>
+            <a:r>
+              <a:rPr sz="2000" b="1">
+                <a:solidFill>
+                  <a:srgbClr val="EE6C4D"/>
+                </a:solidFill>
+              </a:rPr>
+              <a:t>▸  </a:t>
+            </a:r>
+            <a:r>
+              <a:rPr sz="2000">
+                <a:solidFill>
+                  <a:srgbClr val="1F2933"/>
+                </a:solidFill>
+              </a:rPr>
+              <a:t>74 automated tests over the real create → optimise → deliver → track flow.</a:t>
+            </a:r>
+          </a:p>
+          <a:p>
+            <a:pPr>
+              <a:spcAft>
+                <a:spcPts val="1400"/>
+              </a:spcAft>
+            </a:pPr>
+            <a:r>
+              <a:rPr sz="2000" b="1">
+                <a:solidFill>
+                  <a:srgbClr val="EE6C4D"/>
+                </a:solidFill>
+              </a:rPr>
+              <a:t>▸  </a:t>
+            </a:r>
+            <a:r>
+              <a:rPr sz="2000">
+                <a:solidFill>
+                  <a:srgbClr val="1F2933"/>
+                </a:solidFill>
+              </a:rPr>
+              <a:t>Role-protection tests ensure permissions hold; a test verifies every optimiser technique.</a:t>
+            </a:r>
+          </a:p>
+          <a:p>
+            <a:pPr>
+              <a:spcAft>
+                <a:spcPts val="1400"/>
+              </a:spcAft>
+            </a:pPr>
+            <a:r>
+              <a:rPr sz="2000" b="1">
+                <a:solidFill>
+                  <a:srgbClr val="EE6C4D"/>
+                </a:solidFill>
+              </a:rPr>
+              <a:t>▸  </a:t>
+            </a:r>
+            <a:r>
+              <a:rPr sz="2000">
+                <a:solidFill>
+                  <a:srgbClr val="1F2933"/>
+                </a:solidFill>
+              </a:rPr>
+              <a:t>The entire ML layer is tested: ETA/forecast, audit/GIS, NLP/assistant, router, personas.</a:t>
+            </a:r>
+          </a:p>
+          <a:p>
+            <a:pPr>
+              <a:spcAft>
+                <a:spcPts val="1400"/>
+              </a:spcAft>
+            </a:pPr>
+            <a:r>
+              <a:rPr sz="2000" b="1">
+                <a:solidFill>
+                  <a:srgbClr val="EE6C4D"/>
+                </a:solidFill>
+              </a:rPr>
+              <a:t>▸  </a:t>
+            </a:r>
+            <a:r>
+              <a:rPr sz="2000">
+                <a:solidFill>
+                  <a:srgbClr val="1F2933"/>
+                </a:solidFill>
+              </a:rPr>
+              <a:t>All tests pass on the in-memory database.</a:t>
+            </a:r>
+          </a:p>
+        </p:txBody>
+      </p:sp>
+    </p:spTree>
+  </p:cSld>
+  <p:clrMapOvr>
+    <a:masterClrMapping/>
+  </p:clrMapOvr>
+</p:sld>
+</file>
+
+<file path=ppt/slides/slide24.xml><?xml version="1.0" encoding="utf-8"?>
+<p:sld xmlns:a="http://schemas.openxmlformats.org/drawingml/2006/main" xmlns:p="http://schemas.openxmlformats.org/presentationml/2006/main" xmlns:r="http://schemas.openxmlformats.org/officeDocument/2006/relationships">
+  <p:cSld>
+    <p:bg>
+      <p:bgPr>
+        <a:solidFill>
+          <a:srgbClr val="F4F7FB"/>
+        </a:solidFill>
+        <a:effectLst/>
+      </p:bgPr>
+    </p:bg>
+    <p:spTree>
+      <p:nvGrpSpPr>
+        <p:cNvPr id="1" name=""/>
+        <p:cNvGrpSpPr/>
+        <p:nvPr/>
+      </p:nvGrpSpPr>
+      <p:grpSpPr/>
+      <p:sp>
+        <p:nvSpPr>
+          <p:cNvPr id="2" name="Rectangle 1"/>
+          <p:cNvSpPr/>
+          <p:nvPr/>
+        </p:nvSpPr>
+        <p:spPr>
+          <a:xfrm>
+            <a:off x="0" y="0"/>
+            <a:ext cx="12191695" cy="1143000"/>
+          </a:xfrm>
+          <a:prstGeom prst="rect">
+            <a:avLst/>
+          </a:prstGeom>
+          <a:solidFill>
+            <a:srgbClr val="0D3B66"/>
+          </a:solidFill>
+          <a:ln>
+            <a:noFill/>
+          </a:ln>
+        </p:spPr>
+        <p:style>
+          <a:lnRef idx="1">
+            <a:schemeClr val="accent1"/>
+          </a:lnRef>
+          <a:fillRef idx="3">
+            <a:schemeClr val="accent1"/>
+          </a:fillRef>
+          <a:effectRef idx="2">
+            <a:schemeClr val="accent1"/>
+          </a:effectRef>
+          <a:fontRef idx="minor">
+            <a:schemeClr val="lt1"/>
+          </a:fontRef>
+        </p:style>
+        <p:txBody>
+          <a:bodyPr rtlCol="0" anchor="ctr" wrap="square" lIns="548640"/>
+          <a:lstStyle/>
+          <a:p>
+            <a:pPr algn="ctr"/>
+            <a:r>
+              <a:rPr sz="3000" b="1">
+                <a:solidFill>
+                  <a:srgbClr val="FFFFFF"/>
+                </a:solidFill>
+              </a:rPr>
+              <a:t>Future Work</a:t>
+            </a:r>
+          </a:p>
+        </p:txBody>
+      </p:sp>
+      <p:sp>
+        <p:nvSpPr>
+          <p:cNvPr id="3" name="TextBox 2"/>
+          <p:cNvSpPr txBox="1"/>
+          <p:nvPr/>
+        </p:nvSpPr>
+        <p:spPr>
+          <a:xfrm>
+            <a:off x="822960" y="1554480"/>
+            <a:ext cx="10515600" cy="4937760"/>
+          </a:xfrm>
+          <a:prstGeom prst="rect">
+            <a:avLst/>
+          </a:prstGeom>
+          <a:noFill/>
+        </p:spPr>
+        <p:txBody>
+          <a:bodyPr wrap="square">
+            <a:spAutoFit/>
+          </a:bodyPr>
+          <a:lstStyle/>
+          <a:p>
+            <a:pPr>
+              <a:spcAft>
+                <a:spcPts val="1400"/>
+              </a:spcAft>
+            </a:pPr>
+            <a:r>
+              <a:rPr sz="2000" b="1">
+                <a:solidFill>
+                  <a:srgbClr val="EE6C4D"/>
+                </a:solidFill>
+              </a:rPr>
+              <a:t>▸  </a:t>
+            </a:r>
+            <a:r>
+              <a:rPr sz="2000">
+                <a:solidFill>
+                  <a:srgbClr val="1F2933"/>
+                </a:solidFill>
+              </a:rPr>
+              <a:t>A true capacitated VRP solver (OR-Tools) with time windows.</a:t>
+            </a:r>
+          </a:p>
+          <a:p>
+            <a:pPr>
+              <a:spcAft>
+                <a:spcPts val="1400"/>
+              </a:spcAft>
+            </a:pPr>
+            <a:r>
+              <a:rPr sz="2000" b="1">
+                <a:solidFill>
+                  <a:srgbClr val="EE6C4D"/>
+                </a:solidFill>
+              </a:rPr>
+              <a:t>▸  </a:t>
+            </a:r>
+            <a:r>
+              <a:rPr sz="2000">
+                <a:solidFill>
+                  <a:srgbClr val="1F2933"/>
+                </a:solidFill>
+              </a:rPr>
+              <a:t>Validate the predictive models on real operational data.</a:t>
+            </a:r>
+          </a:p>
+          <a:p>
+            <a:pPr>
+              <a:spcAft>
+                <a:spcPts val="1400"/>
+              </a:spcAft>
+            </a:pPr>
+            <a:r>
+              <a:rPr sz="2000" b="1">
+                <a:solidFill>
+                  <a:srgbClr val="EE6C4D"/>
+                </a:solidFill>
+              </a:rPr>
+              <a:t>▸  </a:t>
+            </a:r>
+            <a:r>
+              <a:rPr sz="2000">
+                <a:solidFill>
+                  <a:srgbClr val="1F2933"/>
+                </a:solidFill>
+              </a:rPr>
+              <a:t>Live GPS tracking and dynamic re-routing around incidents.</a:t>
+            </a:r>
+          </a:p>
+          <a:p>
+            <a:pPr>
+              <a:spcAft>
+                <a:spcPts val="1400"/>
+              </a:spcAft>
+            </a:pPr>
+            <a:r>
+              <a:rPr sz="2000" b="1">
+                <a:solidFill>
+                  <a:srgbClr val="EE6C4D"/>
+                </a:solidFill>
+              </a:rPr>
+              <a:t>▸  </a:t>
+            </a:r>
+            <a:r>
+              <a:rPr sz="2000">
+                <a:solidFill>
+                  <a:srgbClr val="1F2933"/>
+                </a:solidFill>
+              </a:rPr>
+              <a:t>SMS / email notifications and cash-on-delivery settlement.</a:t>
+            </a:r>
+          </a:p>
+        </p:txBody>
+      </p:sp>
+    </p:spTree>
+  </p:cSld>
+  <p:clrMapOvr>
+    <a:masterClrMapping/>
+  </p:clrMapOvr>
+</p:sld>
+</file>
+
+<file path=ppt/slides/slide25.xml><?xml version="1.0" encoding="utf-8"?>
 <p:sld xmlns:a="http://schemas.openxmlformats.org/drawingml/2006/main" xmlns:p="http://schemas.openxmlformats.org/presentationml/2006/main" xmlns:r="http://schemas.openxmlformats.org/officeDocument/2006/relationships">
   <p:cSld>
     <p:bg>
@@ -4895,198 +6300,6 @@
           <a:lstStyle/>
           <a:p>
             <a:pPr algn="ctr"/>
-          </a:p>
-        </p:txBody>
-      </p:sp>
-    </p:spTree>
-  </p:cSld>
-  <p:clrMapOvr>
-    <a:masterClrMapping/>
-  </p:clrMapOvr>
-</p:sld>
-</file>
-
-<file path=ppt/slides/slide2.xml><?xml version="1.0" encoding="utf-8"?>
-<p:sld xmlns:a="http://schemas.openxmlformats.org/drawingml/2006/main" xmlns:p="http://schemas.openxmlformats.org/presentationml/2006/main" xmlns:r="http://schemas.openxmlformats.org/officeDocument/2006/relationships">
-  <p:cSld>
-    <p:bg>
-      <p:bgPr>
-        <a:solidFill>
-          <a:srgbClr val="F4F7FB"/>
-        </a:solidFill>
-        <a:effectLst/>
-      </p:bgPr>
-    </p:bg>
-    <p:spTree>
-      <p:nvGrpSpPr>
-        <p:cNvPr id="1" name=""/>
-        <p:cNvGrpSpPr/>
-        <p:nvPr/>
-      </p:nvGrpSpPr>
-      <p:grpSpPr/>
-      <p:sp>
-        <p:nvSpPr>
-          <p:cNvPr id="2" name="Rectangle 1"/>
-          <p:cNvSpPr/>
-          <p:nvPr/>
-        </p:nvSpPr>
-        <p:spPr>
-          <a:xfrm>
-            <a:off x="0" y="0"/>
-            <a:ext cx="12191695" cy="1143000"/>
-          </a:xfrm>
-          <a:prstGeom prst="rect">
-            <a:avLst/>
-          </a:prstGeom>
-          <a:solidFill>
-            <a:srgbClr val="0D3B66"/>
-          </a:solidFill>
-          <a:ln>
-            <a:noFill/>
-          </a:ln>
-        </p:spPr>
-        <p:style>
-          <a:lnRef idx="1">
-            <a:schemeClr val="accent1"/>
-          </a:lnRef>
-          <a:fillRef idx="3">
-            <a:schemeClr val="accent1"/>
-          </a:fillRef>
-          <a:effectRef idx="2">
-            <a:schemeClr val="accent1"/>
-          </a:effectRef>
-          <a:fontRef idx="minor">
-            <a:schemeClr val="lt1"/>
-          </a:fontRef>
-        </p:style>
-        <p:txBody>
-          <a:bodyPr rtlCol="0" anchor="ctr" wrap="square" lIns="548640"/>
-          <a:lstStyle/>
-          <a:p>
-            <a:pPr algn="ctr"/>
-            <a:r>
-              <a:rPr sz="3000" b="1">
-                <a:solidFill>
-                  <a:srgbClr val="FFFFFF"/>
-                </a:solidFill>
-              </a:rPr>
-              <a:t>The Problem</a:t>
-            </a:r>
-          </a:p>
-        </p:txBody>
-      </p:sp>
-      <p:sp>
-        <p:nvSpPr>
-          <p:cNvPr id="3" name="TextBox 2"/>
-          <p:cNvSpPr txBox="1"/>
-          <p:nvPr/>
-        </p:nvSpPr>
-        <p:spPr>
-          <a:xfrm>
-            <a:off x="822960" y="1554480"/>
-            <a:ext cx="10515600" cy="4937760"/>
-          </a:xfrm>
-          <a:prstGeom prst="rect">
-            <a:avLst/>
-          </a:prstGeom>
-          <a:noFill/>
-        </p:spPr>
-        <p:txBody>
-          <a:bodyPr wrap="square">
-            <a:spAutoFit/>
-          </a:bodyPr>
-          <a:lstStyle/>
-          <a:p>
-            <a:pPr>
-              <a:spcAft>
-                <a:spcPts val="1400"/>
-              </a:spcAft>
-            </a:pPr>
-            <a:r>
-              <a:rPr sz="2000" b="1">
-                <a:solidFill>
-                  <a:srgbClr val="EE6C4D"/>
-                </a:solidFill>
-              </a:rPr>
-              <a:t>▸  </a:t>
-            </a:r>
-            <a:r>
-              <a:rPr sz="2000">
-                <a:solidFill>
-                  <a:srgbClr val="1F2933"/>
-                </a:solidFill>
-              </a:rPr>
-              <a:t>E-commerce is booming; last-mile delivery is the bottleneck.</a:t>
-            </a:r>
-          </a:p>
-          <a:p>
-            <a:pPr>
-              <a:spcAft>
-                <a:spcPts val="1400"/>
-              </a:spcAft>
-            </a:pPr>
-            <a:r>
-              <a:rPr sz="2000" b="1">
-                <a:solidFill>
-                  <a:srgbClr val="EE6C4D"/>
-                </a:solidFill>
-              </a:rPr>
-              <a:t>▸  </a:t>
-            </a:r>
-            <a:r>
-              <a:rPr sz="2000">
-                <a:solidFill>
-                  <a:srgbClr val="1F2933"/>
-                </a:solidFill>
-              </a:rPr>
-              <a:t>Manual courier dispatch is slow, uneven and error-prone.</a:t>
-            </a:r>
-          </a:p>
-          <a:p>
-            <a:pPr>
-              <a:spcAft>
-                <a:spcPts val="1400"/>
-              </a:spcAft>
-            </a:pPr>
-            <a:r>
-              <a:rPr sz="2000" b="1">
-                <a:solidFill>
-                  <a:srgbClr val="EE6C4D"/>
-                </a:solidFill>
-              </a:rPr>
-              <a:t>▸  </a:t>
-            </a:r>
-            <a:r>
-              <a:rPr sz="2000">
-                <a:solidFill>
-                  <a:srgbClr val="1F2933"/>
-                </a:solidFill>
-              </a:rPr>
-              <a:t>Customers expect real-time visibility: “where is my parcel?”</a:t>
-            </a:r>
-          </a:p>
-          <a:p>
-            <a:pPr>
-              <a:spcAft>
-                <a:spcPts val="1400"/>
-              </a:spcAft>
-            </a:pPr>
-            <a:r>
-              <a:rPr sz="2000" b="1">
-                <a:solidFill>
-                  <a:srgbClr val="EE6C4D"/>
-                </a:solidFill>
-              </a:rPr>
-              <a:t>▸  </a:t>
-            </a:r>
-            <a:r>
-              <a:rPr sz="2000">
-                <a:solidFill>
-                  <a:srgbClr val="1F2933"/>
-                </a:solidFill>
-              </a:rPr>
-              <a:t>Operations teams lack tools to plan and monitor the fleet.</a:t>
-            </a:r>
           </a:p>
         </p:txBody>
       </p:sp>

</xml_diff>